<commit_message>
Fix Russian technical terminology
</commit_message>
<xml_diff>
--- a/poster/Lapin_Vladislav_DoRA_AIRI_2026_RU.pptx
+++ b/poster/Lapin_Vladislav_DoRA_AIRI_2026_RU.pptx
@@ -2,13 +2,13 @@
 <file path=ppt/presentation.xml><?xml version="1.0" encoding="utf-8"?>
 <p:presentation xmlns:p="http://schemas.openxmlformats.org/presentationml/2006/main">
   <p:sldMasterIdLst>
-    <p:sldMasterId xmlns:r="http://schemas.openxmlformats.org/officeDocument/2006/relationships" id="2147483648" r:id="Rd7dcc4bdac8e413a"/>
+    <p:sldMasterId xmlns:r="http://schemas.openxmlformats.org/officeDocument/2006/relationships" id="2147483648" r:id="R7f4b77f8f1c64782"/>
   </p:sldMasterIdLst>
   <p:notesMasterIdLst>
-    <p:notesMasterId xmlns:r="http://schemas.openxmlformats.org/officeDocument/2006/relationships" r:id="R8506739cfc804c9b"/>
+    <p:notesMasterId xmlns:r="http://schemas.openxmlformats.org/officeDocument/2006/relationships" r:id="R446453cbcd7d430b"/>
   </p:notesMasterIdLst>
   <p:sldIdLst>
-    <p:sldId xmlns:r="http://schemas.openxmlformats.org/officeDocument/2006/relationships" id="256" r:id="R1706cb6865304067"/>
+    <p:sldId xmlns:r="http://schemas.openxmlformats.org/officeDocument/2006/relationships" id="256" r:id="Rf18ade1380da4d98"/>
   </p:sldIdLst>
   <p:sldSz cx="21383625" cy="30275213"/>
   <p:notesSz cx="6858000" cy="9144000"/>
@@ -590,7 +590,7 @@
           <p:nvPr/>
         </p:nvPicPr>
         <p:blipFill>
-          <a:blip xmlns:r="http://schemas.openxmlformats.org/officeDocument/2006/relationships" xmlns:a="http://schemas.openxmlformats.org/drawingml/2006/main" r:embed="Ree74f9860dd04265"/>
+          <a:blip xmlns:r="http://schemas.openxmlformats.org/officeDocument/2006/relationships" xmlns:a="http://schemas.openxmlformats.org/drawingml/2006/main" r:embed="R421984af42414f04"/>
           <a:stretch xmlns:a="http://schemas.openxmlformats.org/drawingml/2006/main">
             <a:fillRect l="0" t="0" r="0" b="0"/>
           </a:stretch>
@@ -614,7 +614,7 @@
           <p:nvPr/>
         </p:nvPicPr>
         <p:blipFill>
-          <a:blip xmlns:r="http://schemas.openxmlformats.org/officeDocument/2006/relationships" xmlns:a="http://schemas.openxmlformats.org/drawingml/2006/main" r:embed="R045ee2482d5a46b9"/>
+          <a:blip xmlns:r="http://schemas.openxmlformats.org/officeDocument/2006/relationships" xmlns:a="http://schemas.openxmlformats.org/drawingml/2006/main" r:embed="R2f92a9c06d084032"/>
           <a:stretch xmlns:a="http://schemas.openxmlformats.org/drawingml/2006/main">
             <a:fillRect l="0" t="0" r="0" b="0"/>
           </a:stretch>
@@ -684,7 +684,7 @@
           <p:nvPr/>
         </p:nvPicPr>
         <p:blipFill>
-          <a:blip xmlns:r="http://schemas.openxmlformats.org/officeDocument/2006/relationships" xmlns:a="http://schemas.openxmlformats.org/drawingml/2006/main" r:embed="R290115cc35194ca3"/>
+          <a:blip xmlns:r="http://schemas.openxmlformats.org/officeDocument/2006/relationships" xmlns:a="http://schemas.openxmlformats.org/drawingml/2006/main" r:embed="Red3accfc0df54936"/>
           <a:stretch xmlns:a="http://schemas.openxmlformats.org/drawingml/2006/main">
             <a:fillRect l="0" t="0" r="0" b="0"/>
           </a:stretch>
@@ -708,7 +708,7 @@
           <p:nvPr/>
         </p:nvPicPr>
         <p:blipFill>
-          <a:blip xmlns:r="http://schemas.openxmlformats.org/officeDocument/2006/relationships" xmlns:a="http://schemas.openxmlformats.org/drawingml/2006/main" r:embed="R8c2a317b7d1349b4"/>
+          <a:blip xmlns:r="http://schemas.openxmlformats.org/officeDocument/2006/relationships" xmlns:a="http://schemas.openxmlformats.org/drawingml/2006/main" r:embed="Rb0d25e7f6895482b"/>
           <a:stretch xmlns:a="http://schemas.openxmlformats.org/drawingml/2006/main">
             <a:fillRect l="0" t="0" r="0" b="0"/>
           </a:stretch>
@@ -875,7 +875,7 @@
   </p:cSld>
   <p:clrMap bg1="lt1" tx1="dk1" bg2="lt2" tx2="dk2" accent1="accent1" accent2="accent2" accent3="accent3" accent4="accent4" accent5="accent5" accent6="accent6" hlink="hlink" folHlink="folHlink"/>
   <p:sldLayoutIdLst>
-    <p:sldLayoutId xmlns:r="http://schemas.openxmlformats.org/officeDocument/2006/relationships" id="2147483649" r:id="R28722d24d207410f"/>
+    <p:sldLayoutId xmlns:r="http://schemas.openxmlformats.org/officeDocument/2006/relationships" id="2147483649" r:id="R90933dc44de84e59"/>
   </p:sldLayoutIdLst>
   <p:txStyles>
     <p:titleStyle>
@@ -1818,7 +1818,7 @@
                 <a:ea typeface="Arial"/>
                 <a:cs typeface="Arial"/>
               </a:rPr>
-              <a:t>Скорректированное методом Холма</a:t>
+              <a:t>Скорректированные методом Холма p-значения: 0.382213 (MLP) / 0.158955 (CNN)</a:t>
             </a:r>
             <a:r>
               <a:rPr sz="2025" b="0">
@@ -1829,7 +1829,7 @@
                 <a:ea typeface="Arial"/>
                 <a:cs typeface="Arial"/>
               </a:rPr>
-              <a:t> p-значение =.382213 (MLP) / .158955 (CNN): внутреннее свидетельство на фиксированных чекпоинтах, а не внешняя (независимая) репликация.</a:t>
+              <a:t>: внутреннее свидетельство на фиксированных чекпоинтах, а не внешняя (независимая) репликация.</a:t>
             </a:r>
           </a:p>
         </p:txBody>
@@ -2461,7 +2461,29 @@
                 <a:ea typeface="Arial"/>
                 <a:cs typeface="Arial"/>
               </a:rPr>
-              <a:t>20 сидов адаптации MLP + 10 CNN; по одному фиксированному чекпоинту; 3 сдвига; семьи Холма m=9 / 6 / 3 (вторичная — описательная).</a:t>
+              <a:t>20 сидов адаптации MLP + 10 CNN; по одному фиксированному чекпоинту; 3 сдвига; </a:t>
+            </a:r>
+            <a:r>
+              <a:rPr sz="2025" b="0">
+                <a:solidFill>
+                  <a:srgbClr val="101820"/>
+                </a:solidFill>
+                <a:latin typeface="Arial"/>
+                <a:ea typeface="Arial"/>
+                <a:cs typeface="Arial"/>
+              </a:rPr>
+              <a:t>семьи сравнений (Холм): m=9 / 6 / 3</a:t>
+            </a:r>
+            <a:r>
+              <a:rPr sz="2025" b="0">
+                <a:solidFill>
+                  <a:srgbClr val="101820"/>
+                </a:solidFill>
+                <a:latin typeface="Arial"/>
+                <a:ea typeface="Arial"/>
+                <a:cs typeface="Arial"/>
+              </a:rPr>
+              <a:t> (вторичная — описательная).</a:t>
             </a:r>
           </a:p>
           <a:p xmlns:a="http://schemas.openxmlformats.org/drawingml/2006/main">
@@ -2513,7 +2535,7 @@
                 <a:ea typeface="Arial"/>
                 <a:cs typeface="Arial"/>
               </a:rPr>
-              <a:t>LoRA+ (фикс. B/A=16), согласованная по бюджету</a:t>
+              <a:t>LoRA+ (фикс. B/A=16), </a:t>
             </a:r>
             <a:r>
               <a:rPr sz="2025" b="0">
@@ -2524,7 +2546,40 @@
                 <a:ea typeface="Arial"/>
                 <a:cs typeface="Arial"/>
               </a:rPr>
-              <a:t> LoRA, DoRA в рамках бюджета и полное дообучение.</a:t>
+              <a:t>согласованная по бюджету параметров LoRA</a:t>
+            </a:r>
+            <a:r>
+              <a:rPr sz="2025" b="0">
+                <a:solidFill>
+                  <a:srgbClr val="101820"/>
+                </a:solidFill>
+                <a:latin typeface="Arial"/>
+                <a:ea typeface="Arial"/>
+                <a:cs typeface="Arial"/>
+              </a:rPr>
+              <a:t>, </a:t>
+            </a:r>
+            <a:r>
+              <a:rPr sz="2025" b="0">
+                <a:solidFill>
+                  <a:srgbClr val="101820"/>
+                </a:solidFill>
+                <a:latin typeface="Arial"/>
+                <a:ea typeface="Arial"/>
+                <a:cs typeface="Arial"/>
+              </a:rPr>
+              <a:t>DoRA в рамках бюджета параметров</a:t>
+            </a:r>
+            <a:r>
+              <a:rPr sz="2025" b="0">
+                <a:solidFill>
+                  <a:srgbClr val="101820"/>
+                </a:solidFill>
+                <a:latin typeface="Arial"/>
+                <a:ea typeface="Arial"/>
+                <a:cs typeface="Arial"/>
+              </a:rPr>
+              <a:t> и полное дообучение.</a:t>
             </a:r>
           </a:p>
           <a:p xmlns:a="http://schemas.openxmlformats.org/drawingml/2006/main">
@@ -2816,7 +2871,29 @@
                 <a:ea typeface="Arial"/>
                 <a:cs typeface="Arial"/>
               </a:rPr>
-              <a:t> согласованная по бюджету LoRA = DoRA = 93.89%.</a:t>
+              <a:t> </a:t>
+            </a:r>
+            <a:r>
+              <a:rPr sz="2025" b="0">
+                <a:solidFill>
+                  <a:srgbClr val="101820"/>
+                </a:solidFill>
+                <a:latin typeface="Arial"/>
+                <a:ea typeface="Arial"/>
+                <a:cs typeface="Arial"/>
+              </a:rPr>
+              <a:t>согласованная по бюджету параметров LoRA</a:t>
+            </a:r>
+            <a:r>
+              <a:rPr sz="2025" b="0">
+                <a:solidFill>
+                  <a:srgbClr val="101820"/>
+                </a:solidFill>
+                <a:latin typeface="Arial"/>
+                <a:ea typeface="Arial"/>
+                <a:cs typeface="Arial"/>
+              </a:rPr>
+              <a:t> = DoRA = 93.89%.</a:t>
             </a:r>
           </a:p>
           <a:p xmlns:a="http://schemas.openxmlformats.org/drawingml/2006/main">
@@ -3149,7 +3226,73 @@
                 <a:ea typeface="Arial"/>
                 <a:cs typeface="Arial"/>
               </a:rPr>
-              <a:t> согласованная по бюджету LoRA оставляет +0.53 п.п.; для DoRA-LoRA+ p, скорректированное методом Холма, =.050935 (&gt; .05); DoRA в рамках бюджета +.82 п.п. (во вторичной семье p, скорректированное методом Холма, =.347089).</a:t>
+              <a:t> </a:t>
+            </a:r>
+            <a:r>
+              <a:rPr sz="2100">
+                <a:solidFill>
+                  <a:srgbClr val="101820"/>
+                </a:solidFill>
+                <a:latin typeface="Arial"/>
+                <a:ea typeface="Arial"/>
+                <a:cs typeface="Arial"/>
+              </a:rPr>
+              <a:t>согласованная по бюджету параметров LoRA</a:t>
+            </a:r>
+            <a:r>
+              <a:rPr sz="2100">
+                <a:solidFill>
+                  <a:srgbClr val="101820"/>
+                </a:solidFill>
+                <a:latin typeface="Arial"/>
+                <a:ea typeface="Arial"/>
+                <a:cs typeface="Arial"/>
+              </a:rPr>
+              <a:t> оставляет +0.53 п.п.; </a:t>
+            </a:r>
+            <a:r>
+              <a:rPr sz="2100">
+                <a:solidFill>
+                  <a:srgbClr val="101820"/>
+                </a:solidFill>
+                <a:latin typeface="Arial"/>
+                <a:ea typeface="Arial"/>
+                <a:cs typeface="Arial"/>
+              </a:rPr>
+              <a:t>для DoRA−LoRA+ p с поправкой Холма = 0.050935 (&gt; 0.05)</a:t>
+            </a:r>
+            <a:r>
+              <a:rPr sz="2100">
+                <a:solidFill>
+                  <a:srgbClr val="101820"/>
+                </a:solidFill>
+                <a:latin typeface="Arial"/>
+                <a:ea typeface="Arial"/>
+                <a:cs typeface="Arial"/>
+              </a:rPr>
+              <a:t>; </a:t>
+            </a:r>
+            <a:r>
+              <a:rPr sz="2100">
+                <a:solidFill>
+                  <a:srgbClr val="101820"/>
+                </a:solidFill>
+                <a:latin typeface="Arial"/>
+                <a:ea typeface="Arial"/>
+                <a:cs typeface="Arial"/>
+              </a:rPr>
+              <a:t>DoRA в рамках бюджета параметров +0.82 п.п. (p с поправкой Холма во вторичной семье сравнений = 0.347089)</a:t>
+            </a:r>
+            <a:r>
+              <a:rPr sz="2100">
+                <a:solidFill>
+                  <a:srgbClr val="101820"/>
+                </a:solidFill>
+                <a:latin typeface="Arial"/>
+                <a:ea typeface="Arial"/>
+                <a:cs typeface="Arial"/>
+              </a:rPr>
+              <a:t>.</a:t>
             </a:r>
           </a:p>
           <a:p xmlns:a="http://schemas.openxmlformats.org/drawingml/2006/main">
@@ -3851,7 +3994,7 @@
                 <a:latin typeface="Arial"/>
                 <a:ea typeface="Arial"/>
                 <a:cs typeface="Arial"/>
-                <a:hlinkClick xmlns:r="http://schemas.openxmlformats.org/officeDocument/2006/relationships" r:id="R61ee8d85eecb4966"/>
+                <a:hlinkClick xmlns:r="http://schemas.openxmlformats.org/officeDocument/2006/relationships" r:id="R6e559c8806e14963"/>
               </a:rPr>
               <a:t>ПРИВАТНАЯ ССЫЛКА</a:t>
             </a:r>
@@ -4204,7 +4347,7 @@
       </p:sp>
       <p:cxnSp>
         <p:nvCxnSpPr>
-          <p:cNvPr id="415" name=""/>
+          <p:cNvPr id="497" name=""/>
           <p:cNvCxnSpPr>
             <a:stCxn xmlns:a="http://schemas.openxmlformats.org/drawingml/2006/main" id="40" idx="3"/>
             <a:endCxn xmlns:a="http://schemas.openxmlformats.org/drawingml/2006/main" id="41" idx="1"/>
@@ -4230,7 +4373,7 @@
       </p:cxnSp>
       <p:cxnSp>
         <p:nvCxnSpPr>
-          <p:cNvPr id="416" name=""/>
+          <p:cNvPr id="498" name=""/>
           <p:cNvCxnSpPr>
             <a:stCxn xmlns:a="http://schemas.openxmlformats.org/drawingml/2006/main" id="41" idx="3"/>
             <a:endCxn xmlns:a="http://schemas.openxmlformats.org/drawingml/2006/main" id="42" idx="1"/>
@@ -4528,7 +4671,7 @@
       </p:sp>
       <p:cxnSp>
         <p:nvCxnSpPr>
-          <p:cNvPr id="421" name=""/>
+          <p:cNvPr id="503" name=""/>
           <p:cNvCxnSpPr>
             <a:stCxn xmlns:a="http://schemas.openxmlformats.org/drawingml/2006/main" id="45" idx="3"/>
             <a:endCxn xmlns:a="http://schemas.openxmlformats.org/drawingml/2006/main" id="46" idx="1"/>
@@ -4554,7 +4697,7 @@
       </p:cxnSp>
       <p:cxnSp>
         <p:nvCxnSpPr>
-          <p:cNvPr id="422" name=""/>
+          <p:cNvPr id="504" name=""/>
           <p:cNvCxnSpPr>
             <a:stCxn xmlns:a="http://schemas.openxmlformats.org/drawingml/2006/main" id="46" idx="3"/>
             <a:endCxn xmlns:a="http://schemas.openxmlformats.org/drawingml/2006/main" id="47" idx="1"/>
@@ -4580,7 +4723,7 @@
       </p:cxnSp>
       <p:cxnSp>
         <p:nvCxnSpPr>
-          <p:cNvPr id="423" name=""/>
+          <p:cNvPr id="505" name=""/>
           <p:cNvCxnSpPr>
             <a:stCxn xmlns:a="http://schemas.openxmlformats.org/drawingml/2006/main" id="47" idx="3"/>
             <a:endCxn xmlns:a="http://schemas.openxmlformats.org/drawingml/2006/main" id="48" idx="1"/>
@@ -4816,14 +4959,14 @@
       </p:sp>
       <p:pic>
         <p:nvPicPr>
-          <p:cNvPr id="427" name=""/>
+          <p:cNvPr id="509" name=""/>
           <p:cNvPicPr>
             <a:picLocks xmlns:a="http://schemas.openxmlformats.org/drawingml/2006/main" noChangeAspect="1"/>
           </p:cNvPicPr>
           <p:nvPr/>
         </p:nvPicPr>
         <p:blipFill>
-          <a:blip xmlns:r="http://schemas.openxmlformats.org/officeDocument/2006/relationships" xmlns:a="http://schemas.openxmlformats.org/drawingml/2006/main" r:embed="Rbd72debc9dc14d43"/>
+          <a:blip xmlns:r="http://schemas.openxmlformats.org/officeDocument/2006/relationships" xmlns:a="http://schemas.openxmlformats.org/drawingml/2006/main" r:embed="R3fcd92a128714951"/>
           <a:stretch xmlns:a="http://schemas.openxmlformats.org/drawingml/2006/main"/>
         </p:blipFill>
         <p:spPr>
@@ -4838,14 +4981,14 @@
       </p:pic>
       <p:pic>
         <p:nvPicPr>
-          <p:cNvPr id="428" name=""/>
+          <p:cNvPr id="510" name=""/>
           <p:cNvPicPr>
             <a:picLocks xmlns:a="http://schemas.openxmlformats.org/drawingml/2006/main" noChangeAspect="1"/>
           </p:cNvPicPr>
           <p:nvPr/>
         </p:nvPicPr>
         <p:blipFill>
-          <a:blip xmlns:r="http://schemas.openxmlformats.org/officeDocument/2006/relationships" xmlns:a="http://schemas.openxmlformats.org/drawingml/2006/main" r:embed="R48e8e0d313ef4212"/>
+          <a:blip xmlns:r="http://schemas.openxmlformats.org/officeDocument/2006/relationships" xmlns:a="http://schemas.openxmlformats.org/drawingml/2006/main" r:embed="Rb45cad69b5c1488c"/>
           <a:stretch xmlns:a="http://schemas.openxmlformats.org/drawingml/2006/main"/>
         </p:blipFill>
         <p:spPr>

</xml_diff>

<commit_message>
Polish Russian poster terminology
</commit_message>
<xml_diff>
--- a/poster/Lapin_Vladislav_DoRA_AIRI_2026_RU.pptx
+++ b/poster/Lapin_Vladislav_DoRA_AIRI_2026_RU.pptx
@@ -2,13 +2,13 @@
 <file path=ppt/presentation.xml><?xml version="1.0" encoding="utf-8"?>
 <p:presentation xmlns:p="http://schemas.openxmlformats.org/presentationml/2006/main">
   <p:sldMasterIdLst>
-    <p:sldMasterId xmlns:r="http://schemas.openxmlformats.org/officeDocument/2006/relationships" id="2147483648" r:id="R7f4b77f8f1c64782"/>
+    <p:sldMasterId xmlns:r="http://schemas.openxmlformats.org/officeDocument/2006/relationships" id="2147483648" r:id="R26fdd3811d1342e7"/>
   </p:sldMasterIdLst>
   <p:notesMasterIdLst>
-    <p:notesMasterId xmlns:r="http://schemas.openxmlformats.org/officeDocument/2006/relationships" r:id="R446453cbcd7d430b"/>
+    <p:notesMasterId xmlns:r="http://schemas.openxmlformats.org/officeDocument/2006/relationships" r:id="R958b41af487e48c9"/>
   </p:notesMasterIdLst>
   <p:sldIdLst>
-    <p:sldId xmlns:r="http://schemas.openxmlformats.org/officeDocument/2006/relationships" id="256" r:id="Rf18ade1380da4d98"/>
+    <p:sldId xmlns:r="http://schemas.openxmlformats.org/officeDocument/2006/relationships" id="256" r:id="Raad06fd4d96d4f58"/>
   </p:sldIdLst>
   <p:sldSz cx="21383625" cy="30275213"/>
   <p:notesSz cx="6858000" cy="9144000"/>
@@ -590,7 +590,7 @@
           <p:nvPr/>
         </p:nvPicPr>
         <p:blipFill>
-          <a:blip xmlns:r="http://schemas.openxmlformats.org/officeDocument/2006/relationships" xmlns:a="http://schemas.openxmlformats.org/drawingml/2006/main" r:embed="R421984af42414f04"/>
+          <a:blip xmlns:r="http://schemas.openxmlformats.org/officeDocument/2006/relationships" xmlns:a="http://schemas.openxmlformats.org/drawingml/2006/main" r:embed="R1bbf811d77a54726"/>
           <a:stretch xmlns:a="http://schemas.openxmlformats.org/drawingml/2006/main">
             <a:fillRect l="0" t="0" r="0" b="0"/>
           </a:stretch>
@@ -614,7 +614,7 @@
           <p:nvPr/>
         </p:nvPicPr>
         <p:blipFill>
-          <a:blip xmlns:r="http://schemas.openxmlformats.org/officeDocument/2006/relationships" xmlns:a="http://schemas.openxmlformats.org/drawingml/2006/main" r:embed="R2f92a9c06d084032"/>
+          <a:blip xmlns:r="http://schemas.openxmlformats.org/officeDocument/2006/relationships" xmlns:a="http://schemas.openxmlformats.org/drawingml/2006/main" r:embed="R86837004193b4ab1"/>
           <a:stretch xmlns:a="http://schemas.openxmlformats.org/drawingml/2006/main">
             <a:fillRect l="0" t="0" r="0" b="0"/>
           </a:stretch>
@@ -684,7 +684,7 @@
           <p:nvPr/>
         </p:nvPicPr>
         <p:blipFill>
-          <a:blip xmlns:r="http://schemas.openxmlformats.org/officeDocument/2006/relationships" xmlns:a="http://schemas.openxmlformats.org/drawingml/2006/main" r:embed="Red3accfc0df54936"/>
+          <a:blip xmlns:r="http://schemas.openxmlformats.org/officeDocument/2006/relationships" xmlns:a="http://schemas.openxmlformats.org/drawingml/2006/main" r:embed="Rad80de65a3344e93"/>
           <a:stretch xmlns:a="http://schemas.openxmlformats.org/drawingml/2006/main">
             <a:fillRect l="0" t="0" r="0" b="0"/>
           </a:stretch>
@@ -708,7 +708,7 @@
           <p:nvPr/>
         </p:nvPicPr>
         <p:blipFill>
-          <a:blip xmlns:r="http://schemas.openxmlformats.org/officeDocument/2006/relationships" xmlns:a="http://schemas.openxmlformats.org/drawingml/2006/main" r:embed="Rb0d25e7f6895482b"/>
+          <a:blip xmlns:r="http://schemas.openxmlformats.org/officeDocument/2006/relationships" xmlns:a="http://schemas.openxmlformats.org/drawingml/2006/main" r:embed="R69b09ebfff0d47e3"/>
           <a:stretch xmlns:a="http://schemas.openxmlformats.org/drawingml/2006/main">
             <a:fillRect l="0" t="0" r="0" b="0"/>
           </a:stretch>
@@ -875,7 +875,7 @@
   </p:cSld>
   <p:clrMap bg1="lt1" tx1="dk1" bg2="lt2" tx2="dk2" accent1="accent1" accent2="accent2" accent3="accent3" accent4="accent4" accent5="accent5" accent6="accent6" hlink="hlink" folHlink="folHlink"/>
   <p:sldLayoutIdLst>
-    <p:sldLayoutId xmlns:r="http://schemas.openxmlformats.org/officeDocument/2006/relationships" id="2147483649" r:id="R90933dc44de84e59"/>
+    <p:sldLayoutId xmlns:r="http://schemas.openxmlformats.org/officeDocument/2006/relationships" id="2147483649" r:id="Ra77e0905e3f44cc6"/>
   </p:sldLayoutIdLst>
   <p:txStyles>
     <p:titleStyle>
@@ -2568,7 +2568,7 @@
                 <a:ea typeface="Arial"/>
                 <a:cs typeface="Arial"/>
               </a:rPr>
-              <a:t>DoRA в рамках бюджета параметров</a:t>
+              <a:t>DoRA в рамках бюджета параметров LoRA</a:t>
             </a:r>
             <a:r>
               <a:rPr sz="2025" b="0">
@@ -3174,7 +3174,29 @@
                 <a:ea typeface="Arial"/>
                 <a:cs typeface="Arial"/>
               </a:rPr>
-              <a:t> DoRA достигает 75.22% (MLP) и 80.53% (CNN), близко к полному дообучению (75.17%, 80.67%), при ~12-15% обучаемых параметров.</a:t>
+              <a:t> DoRA достигает 75.22% (MLP) и 80.53% (CNN), близко к полному дообучению (75.17%, 80.67%), при </a:t>
+            </a:r>
+            <a:r>
+              <a:rPr sz="2100">
+                <a:solidFill>
+                  <a:srgbClr val="101820"/>
+                </a:solidFill>
+                <a:latin typeface="Arial"/>
+                <a:ea typeface="Arial"/>
+                <a:cs typeface="Arial"/>
+              </a:rPr>
+              <a:t>≈12–15%</a:t>
+            </a:r>
+            <a:r>
+              <a:rPr sz="2100">
+                <a:solidFill>
+                  <a:srgbClr val="101820"/>
+                </a:solidFill>
+                <a:latin typeface="Arial"/>
+                <a:ea typeface="Arial"/>
+                <a:cs typeface="Arial"/>
+              </a:rPr>
+              <a:t> обучаемых параметров.</a:t>
             </a:r>
           </a:p>
           <a:p xmlns:a="http://schemas.openxmlformats.org/drawingml/2006/main">
@@ -3281,7 +3303,18 @@
                 <a:ea typeface="Arial"/>
                 <a:cs typeface="Arial"/>
               </a:rPr>
-              <a:t>DoRA в рамках бюджета параметров +0.82 п.п. (p с поправкой Холма во вторичной семье сравнений = 0.347089)</a:t>
+              <a:t>DoRA в рамках бюджета параметров LoRA: +0.82 п.п.</a:t>
+            </a:r>
+            <a:r>
+              <a:rPr sz="2100">
+                <a:solidFill>
+                  <a:srgbClr val="101820"/>
+                </a:solidFill>
+                <a:latin typeface="Arial"/>
+                <a:ea typeface="Arial"/>
+                <a:cs typeface="Arial"/>
+              </a:rPr>
+              <a:t> (p с поправкой Холма во вторичной семье сравнений = 0.347089)</a:t>
             </a:r>
             <a:r>
               <a:rPr sz="2100">
@@ -3333,7 +3366,29 @@
                 <a:ea typeface="Arial"/>
                 <a:cs typeface="Arial"/>
               </a:rPr>
-              <a:t>Синтетическая диагностика (gamma=.8):</a:t>
+              <a:t>Синтетическая диагностика (</a:t>
+            </a:r>
+            <a:r>
+              <a:rPr sz="2100" b="1">
+                <a:solidFill>
+                  <a:srgbClr val="101820"/>
+                </a:solidFill>
+                <a:latin typeface="Arial"/>
+                <a:ea typeface="Arial"/>
+                <a:cs typeface="Arial"/>
+              </a:rPr>
+              <a:t>γ=0.8</a:t>
+            </a:r>
+            <a:r>
+              <a:rPr sz="2100" b="1">
+                <a:solidFill>
+                  <a:srgbClr val="101820"/>
+                </a:solidFill>
+                <a:latin typeface="Arial"/>
+                <a:ea typeface="Arial"/>
+                <a:cs typeface="Arial"/>
+              </a:rPr>
+              <a:t>):</a:t>
             </a:r>
             <a:r>
               <a:rPr sz="2100">
@@ -3344,7 +3399,29 @@
                 <a:ea typeface="Arial"/>
                 <a:cs typeface="Arial"/>
               </a:rPr>
-              <a:t> DoRA представляет цель точно; 44/50 запусков достигают ошибки &lt;10^-3. Средняя ошибка оракула LoRA — .289.</a:t>
+              <a:t> DoRA представляет цель точно; 44/50 запусков достигают ошибки &lt;10^-3. </a:t>
+            </a:r>
+            <a:r>
+              <a:rPr sz="2100">
+                <a:solidFill>
+                  <a:srgbClr val="101820"/>
+                </a:solidFill>
+                <a:latin typeface="Arial"/>
+                <a:ea typeface="Arial"/>
+                <a:cs typeface="Arial"/>
+              </a:rPr>
+              <a:t>Средняя ошибка оракула LoRA — 0.289</a:t>
+            </a:r>
+            <a:r>
+              <a:rPr sz="2100">
+                <a:solidFill>
+                  <a:srgbClr val="101820"/>
+                </a:solidFill>
+                <a:latin typeface="Arial"/>
+                <a:ea typeface="Arial"/>
+                <a:cs typeface="Arial"/>
+              </a:rPr>
+              <a:t>.</a:t>
             </a:r>
           </a:p>
           <a:p xmlns:a="http://schemas.openxmlformats.org/drawingml/2006/main">
@@ -3994,7 +4071,7 @@
                 <a:latin typeface="Arial"/>
                 <a:ea typeface="Arial"/>
                 <a:cs typeface="Arial"/>
-                <a:hlinkClick xmlns:r="http://schemas.openxmlformats.org/officeDocument/2006/relationships" r:id="R6e559c8806e14963"/>
+                <a:hlinkClick xmlns:r="http://schemas.openxmlformats.org/officeDocument/2006/relationships" r:id="Re0b1fd3dd290443d"/>
               </a:rPr>
               <a:t>ПРИВАТНАЯ ССЫЛКА</a:t>
             </a:r>
@@ -4966,7 +5043,7 @@
           <p:nvPr/>
         </p:nvPicPr>
         <p:blipFill>
-          <a:blip xmlns:r="http://schemas.openxmlformats.org/officeDocument/2006/relationships" xmlns:a="http://schemas.openxmlformats.org/drawingml/2006/main" r:embed="R3fcd92a128714951"/>
+          <a:blip xmlns:r="http://schemas.openxmlformats.org/officeDocument/2006/relationships" xmlns:a="http://schemas.openxmlformats.org/drawingml/2006/main" r:embed="R471a8c1264c64e06"/>
           <a:stretch xmlns:a="http://schemas.openxmlformats.org/drawingml/2006/main"/>
         </p:blipFill>
         <p:spPr>
@@ -4988,7 +5065,7 @@
           <p:nvPr/>
         </p:nvPicPr>
         <p:blipFill>
-          <a:blip xmlns:r="http://schemas.openxmlformats.org/officeDocument/2006/relationships" xmlns:a="http://schemas.openxmlformats.org/drawingml/2006/main" r:embed="Rb45cad69b5c1488c"/>
+          <a:blip xmlns:r="http://schemas.openxmlformats.org/officeDocument/2006/relationships" xmlns:a="http://schemas.openxmlformats.org/drawingml/2006/main" r:embed="R4f9eb7324a894056"/>
           <a:stretch xmlns:a="http://schemas.openxmlformats.org/drawingml/2006/main"/>
         </p:blipFill>
         <p:spPr>

</xml_diff>

<commit_message>
Improve Russian poster A1 readability
</commit_message>
<xml_diff>
--- a/poster/Lapin_Vladislav_DoRA_AIRI_2026_RU.pptx
+++ b/poster/Lapin_Vladislav_DoRA_AIRI_2026_RU.pptx
@@ -2,13 +2,13 @@
 <file path=ppt/presentation.xml><?xml version="1.0" encoding="utf-8"?>
 <p:presentation xmlns:p="http://schemas.openxmlformats.org/presentationml/2006/main">
   <p:sldMasterIdLst>
-    <p:sldMasterId xmlns:r="http://schemas.openxmlformats.org/officeDocument/2006/relationships" id="2147483648" r:id="R26fdd3811d1342e7"/>
+    <p:sldMasterId xmlns:r="http://schemas.openxmlformats.org/officeDocument/2006/relationships" id="2147483648" r:id="R969364674e8f4aa9"/>
   </p:sldMasterIdLst>
   <p:notesMasterIdLst>
-    <p:notesMasterId xmlns:r="http://schemas.openxmlformats.org/officeDocument/2006/relationships" r:id="R958b41af487e48c9"/>
+    <p:notesMasterId xmlns:r="http://schemas.openxmlformats.org/officeDocument/2006/relationships" r:id="Ra235a33a79914086"/>
   </p:notesMasterIdLst>
   <p:sldIdLst>
-    <p:sldId xmlns:r="http://schemas.openxmlformats.org/officeDocument/2006/relationships" id="256" r:id="Raad06fd4d96d4f58"/>
+    <p:sldId xmlns:r="http://schemas.openxmlformats.org/officeDocument/2006/relationships" id="256" r:id="Ra987fbf7cc2d4081"/>
   </p:sldIdLst>
   <p:sldSz cx="21383625" cy="30275213"/>
   <p:notesSz cx="6858000" cy="9144000"/>
@@ -590,7 +590,7 @@
           <p:nvPr/>
         </p:nvPicPr>
         <p:blipFill>
-          <a:blip xmlns:r="http://schemas.openxmlformats.org/officeDocument/2006/relationships" xmlns:a="http://schemas.openxmlformats.org/drawingml/2006/main" r:embed="R1bbf811d77a54726"/>
+          <a:blip xmlns:r="http://schemas.openxmlformats.org/officeDocument/2006/relationships" xmlns:a="http://schemas.openxmlformats.org/drawingml/2006/main" r:embed="R317ad2146d864531"/>
           <a:stretch xmlns:a="http://schemas.openxmlformats.org/drawingml/2006/main">
             <a:fillRect l="0" t="0" r="0" b="0"/>
           </a:stretch>
@@ -614,7 +614,7 @@
           <p:nvPr/>
         </p:nvPicPr>
         <p:blipFill>
-          <a:blip xmlns:r="http://schemas.openxmlformats.org/officeDocument/2006/relationships" xmlns:a="http://schemas.openxmlformats.org/drawingml/2006/main" r:embed="R86837004193b4ab1"/>
+          <a:blip xmlns:r="http://schemas.openxmlformats.org/officeDocument/2006/relationships" xmlns:a="http://schemas.openxmlformats.org/drawingml/2006/main" r:embed="R67f27bce20674667"/>
           <a:stretch xmlns:a="http://schemas.openxmlformats.org/drawingml/2006/main">
             <a:fillRect l="0" t="0" r="0" b="0"/>
           </a:stretch>
@@ -684,7 +684,7 @@
           <p:nvPr/>
         </p:nvPicPr>
         <p:blipFill>
-          <a:blip xmlns:r="http://schemas.openxmlformats.org/officeDocument/2006/relationships" xmlns:a="http://schemas.openxmlformats.org/drawingml/2006/main" r:embed="Rad80de65a3344e93"/>
+          <a:blip xmlns:r="http://schemas.openxmlformats.org/officeDocument/2006/relationships" xmlns:a="http://schemas.openxmlformats.org/drawingml/2006/main" r:embed="Rde390f389e9b4f8d"/>
           <a:stretch xmlns:a="http://schemas.openxmlformats.org/drawingml/2006/main">
             <a:fillRect l="0" t="0" r="0" b="0"/>
           </a:stretch>
@@ -708,7 +708,7 @@
           <p:nvPr/>
         </p:nvPicPr>
         <p:blipFill>
-          <a:blip xmlns:r="http://schemas.openxmlformats.org/officeDocument/2006/relationships" xmlns:a="http://schemas.openxmlformats.org/drawingml/2006/main" r:embed="R69b09ebfff0d47e3"/>
+          <a:blip xmlns:r="http://schemas.openxmlformats.org/officeDocument/2006/relationships" xmlns:a="http://schemas.openxmlformats.org/drawingml/2006/main" r:embed="R7644c75b0b2149c4"/>
           <a:stretch xmlns:a="http://schemas.openxmlformats.org/drawingml/2006/main">
             <a:fillRect l="0" t="0" r="0" b="0"/>
           </a:stretch>
@@ -875,7 +875,7 @@
   </p:cSld>
   <p:clrMap bg1="lt1" tx1="dk1" bg2="lt2" tx2="dk2" accent1="accent1" accent2="accent2" accent3="accent3" accent4="accent4" accent5="accent5" accent6="accent6" hlink="hlink" folHlink="folHlink"/>
   <p:sldLayoutIdLst>
-    <p:sldLayoutId xmlns:r="http://schemas.openxmlformats.org/officeDocument/2006/relationships" id="2147483649" r:id="Ra77e0905e3f44cc6"/>
+    <p:sldLayoutId xmlns:r="http://schemas.openxmlformats.org/officeDocument/2006/relationships" id="2147483649" r:id="R3ac3a0a19dd0442b"/>
   </p:sldLayoutIdLst>
   <p:txStyles>
     <p:titleStyle>
@@ -1766,70 +1766,59 @@
               </a:defRPr>
             </a:pPr>
             <a:r>
-              <a:rPr sz="2025" b="1">
-                <a:solidFill>
-                  <a:srgbClr val="101820"/>
-                </a:solidFill>
-                <a:latin typeface="Arial"/>
-                <a:ea typeface="Arial"/>
-                <a:cs typeface="Arial"/>
-              </a:rPr>
-              <a:t>15/20</a:t>
-            </a:r>
-            <a:r>
-              <a:rPr sz="2025" b="0">
-                <a:solidFill>
-                  <a:srgbClr val="101820"/>
-                </a:solidFill>
-                <a:latin typeface="Arial"/>
-                <a:ea typeface="Arial"/>
-                <a:cs typeface="Arial"/>
-              </a:rPr>
-              <a:t> пар MLP и </a:t>
-            </a:r>
-            <a:r>
-              <a:rPr sz="2025" b="1">
-                <a:solidFill>
-                  <a:srgbClr val="101820"/>
-                </a:solidFill>
-                <a:latin typeface="Arial"/>
-                <a:ea typeface="Arial"/>
-                <a:cs typeface="Arial"/>
-              </a:rPr>
-              <a:t>8/10</a:t>
-            </a:r>
-            <a:r>
-              <a:rPr sz="2025" b="0">
-                <a:solidFill>
-                  <a:srgbClr val="101820"/>
-                </a:solidFill>
-                <a:latin typeface="Arial"/>
-                <a:ea typeface="Arial"/>
-                <a:cs typeface="Arial"/>
-              </a:rPr>
-              <a:t> пар CNN отдали преимущество DoRA. </a:t>
-            </a:r>
-            <a:r>
-              <a:rPr sz="2025" b="1">
-                <a:solidFill>
-                  <a:srgbClr val="101820"/>
-                </a:solidFill>
-                <a:latin typeface="Arial"/>
-                <a:ea typeface="Arial"/>
-                <a:cs typeface="Arial"/>
-              </a:rPr>
-              <a:t>Скорректированные методом Холма p-значения: 0.382213 (MLP) / 0.158955 (CNN)</a:t>
-            </a:r>
-            <a:r>
-              <a:rPr sz="2025" b="0">
-                <a:solidFill>
-                  <a:srgbClr val="101820"/>
-                </a:solidFill>
-                <a:latin typeface="Arial"/>
-                <a:ea typeface="Arial"/>
-                <a:cs typeface="Arial"/>
-              </a:rPr>
-              <a:t>: внутреннее свидетельство на фиксированных чекпоинтах, а не внешняя (независимая) репликация.</a:t>
+              <a:rPr sz="2400" b="1">
+                <a:solidFill>
+                  <a:srgbClr val="101820"/>
+                </a:solidFill>
+                <a:latin typeface="Arial"/>
+                <a:ea typeface="Arial"/>
+                <a:cs typeface="Arial"/>
+              </a:rPr>
+              <a:t>15/20 пар MLP и 8/10 пар CNN — в пользу DoRA.</a:t>
+            </a:r>
+            <a:r>
+              <a:rPr sz="2400" b="0">
+                <a:solidFill>
+                  <a:srgbClr val="101820"/>
+                </a:solidFill>
+                <a:latin typeface="Arial"/>
+                <a:ea typeface="Arial"/>
+                <a:cs typeface="Arial"/>
+              </a:rPr>
+              <a:t> </a:t>
+            </a:r>
+            <a:r>
+              <a:rPr sz="2400" b="1">
+                <a:solidFill>
+                  <a:srgbClr val="101820"/>
+                </a:solidFill>
+                <a:latin typeface="Arial"/>
+                <a:ea typeface="Arial"/>
+                <a:cs typeface="Arial"/>
+              </a:rPr>
+              <a:t>p с поправкой Холма:</a:t>
+            </a:r>
+            <a:r>
+              <a:rPr sz="2400" b="1">
+                <a:solidFill>
+                  <a:srgbClr val="101820"/>
+                </a:solidFill>
+                <a:latin typeface="Arial"/>
+                <a:ea typeface="Arial"/>
+                <a:cs typeface="Arial"/>
+              </a:rPr>
+              <a:t> 0.382213 (MLP) / 0.158955 (CNN)</a:t>
+            </a:r>
+            <a:r>
+              <a:rPr sz="2400" b="0">
+                <a:solidFill>
+                  <a:srgbClr val="101820"/>
+                </a:solidFill>
+                <a:latin typeface="Arial"/>
+                <a:ea typeface="Arial"/>
+                <a:cs typeface="Arial"/>
+              </a:rPr>
+              <a:t>. Условные эффекты на фиксированных чекпоинтах; это не внешняя (независимая) репликация.</a:t>
             </a:r>
           </a:p>
         </p:txBody>
@@ -1965,15 +1954,15 @@
               </a:defRPr>
             </a:pPr>
             <a:r>
-              <a:rPr sz="3225" b="0">
-                <a:solidFill>
-                  <a:srgbClr val="101820"/>
-                </a:solidFill>
-                <a:latin typeface="Arial"/>
-                <a:ea typeface="Arial"/>
-                <a:cs typeface="Arial"/>
-              </a:rPr>
-              <a:t>Зачем отделять величину от направления?</a:t>
+              <a:rPr sz="3600" b="0">
+                <a:solidFill>
+                  <a:srgbClr val="101820"/>
+                </a:solidFill>
+                <a:latin typeface="Arial"/>
+                <a:ea typeface="Arial"/>
+                <a:cs typeface="Arial"/>
+              </a:rPr>
+              <a:t>Норма и направление</a:t>
             </a:r>
           </a:p>
         </p:txBody>
@@ -2315,15 +2304,15 @@
               </a:defRPr>
             </a:pPr>
             <a:r>
-              <a:rPr sz="3225" b="0">
-                <a:solidFill>
-                  <a:srgbClr val="101820"/>
-                </a:solidFill>
-                <a:latin typeface="Arial"/>
-                <a:ea typeface="Arial"/>
-                <a:cs typeface="Arial"/>
-              </a:rPr>
-              <a:t>Протокол зафиксирован до оценки на удержанных сидах</a:t>
+              <a:rPr sz="3600" b="0">
+                <a:solidFill>
+                  <a:srgbClr val="101820"/>
+                </a:solidFill>
+                <a:latin typeface="Arial"/>
+                <a:ea typeface="Arial"/>
+                <a:cs typeface="Arial"/>
+              </a:rPr>
+              <a:t>Протокол зафиксирован до оценки</a:t>
             </a:r>
           </a:p>
         </p:txBody>
@@ -2736,15 +2725,15 @@
               </a:defRPr>
             </a:pPr>
             <a:r>
-              <a:rPr sz="3225" b="0">
-                <a:solidFill>
-                  <a:srgbClr val="101820"/>
-                </a:solidFill>
-                <a:latin typeface="Arial"/>
-                <a:ea typeface="Arial"/>
-                <a:cs typeface="Arial"/>
-              </a:rPr>
-              <a:t>Негативные контроли не позволяют представить только победы DoRA</a:t>
+              <a:rPr sz="3600" b="0">
+                <a:solidFill>
+                  <a:srgbClr val="101820"/>
+                </a:solidFill>
+                <a:latin typeface="Arial"/>
+                <a:ea typeface="Arial"/>
+                <a:cs typeface="Arial"/>
+              </a:rPr>
+              <a:t>Негативные контроли: ограничения</a:t>
             </a:r>
           </a:p>
         </p:txBody>
@@ -3069,15 +3058,15 @@
               </a:defRPr>
             </a:pPr>
             <a:r>
-              <a:rPr sz="3225" b="0">
-                <a:solidFill>
-                  <a:srgbClr val="101820"/>
-                </a:solidFill>
-                <a:latin typeface="Arial"/>
-                <a:ea typeface="Arial"/>
-                <a:cs typeface="Arial"/>
-              </a:rPr>
-              <a:t>Что всё же подтверждают контрольные проверки</a:t>
+              <a:rPr sz="3600" b="0">
+                <a:solidFill>
+                  <a:srgbClr val="101820"/>
+                </a:solidFill>
+                <a:latin typeface="Arial"/>
+                <a:ea typeface="Arial"/>
+                <a:cs typeface="Arial"/>
+              </a:rPr>
+              <a:t>Что подтверждают проверки</a:t>
             </a:r>
           </a:p>
         </p:txBody>
@@ -3537,7 +3526,7 @@
               </a:defRPr>
             </a:pPr>
             <a:r>
-              <a:rPr sz="1725" b="1">
+              <a:rPr sz="3600" b="1">
                 <a:solidFill>
                   <a:srgbClr val="008A80"/>
                 </a:solidFill>
@@ -3545,7 +3534,7 @@
                 <a:ea typeface="Arial"/>
                 <a:cs typeface="Arial"/>
               </a:rPr>
-              <a:t>СМЕШАННЫЙ СДВИГ: ОЦЕНКИ НА УДЕРЖАННЫХ СИДАХ</a:t>
+              <a:t>СМЕШАННЫЙ СДВИГ</a:t>
             </a:r>
           </a:p>
         </p:txBody>
@@ -3612,7 +3601,7 @@
               </a:defRPr>
             </a:pPr>
             <a:r>
-              <a:rPr sz="1650" b="0">
+              <a:rPr sz="2400" b="0">
                 <a:solidFill>
                   <a:srgbClr val="5F6870"/>
                 </a:solidFill>
@@ -3620,7 +3609,7 @@
                 <a:ea typeface="Arial"/>
                 <a:cs typeface="Arial"/>
               </a:rPr>
-              <a:t>Целевая тестовая выборка оценивалась по протоколу, зафиксированному после выбора по валидации. Внутреннее подтверждение на фиксированных чекпоинтах; точные ДИ, исходные/скорректированные p и бюджеты ранга — в репозитории.</a:t>
+              <a:t>Внутреннее подтверждение на фиксированных чекпоинтах; не внешняя репликация.</a:t>
             </a:r>
           </a:p>
         </p:txBody>
@@ -4064,14 +4053,14 @@
               </a:defRPr>
             </a:pPr>
             <a:r>
-              <a:rPr sz="1275" b="1">
+              <a:rPr sz="2250" b="1">
                 <a:solidFill>
                   <a:srgbClr val="008A80"/>
                 </a:solidFill>
                 <a:latin typeface="Arial"/>
                 <a:ea typeface="Arial"/>
                 <a:cs typeface="Arial"/>
-                <a:hlinkClick xmlns:r="http://schemas.openxmlformats.org/officeDocument/2006/relationships" r:id="Re0b1fd3dd290443d"/>
+                <a:hlinkClick xmlns:r="http://schemas.openxmlformats.org/officeDocument/2006/relationships" r:id="R71bf5d17eeba4a4f"/>
               </a:rPr>
               <a:t>ПРИВАТНАЯ ССЫЛКА</a:t>
             </a:r>
@@ -5043,7 +5032,7 @@
           <p:nvPr/>
         </p:nvPicPr>
         <p:blipFill>
-          <a:blip xmlns:r="http://schemas.openxmlformats.org/officeDocument/2006/relationships" xmlns:a="http://schemas.openxmlformats.org/drawingml/2006/main" r:embed="R471a8c1264c64e06"/>
+          <a:blip xmlns:r="http://schemas.openxmlformats.org/officeDocument/2006/relationships" xmlns:a="http://schemas.openxmlformats.org/drawingml/2006/main" r:embed="Rf3f9f6ccce664a1c"/>
           <a:stretch xmlns:a="http://schemas.openxmlformats.org/drawingml/2006/main"/>
         </p:blipFill>
         <p:spPr>
@@ -5065,7 +5054,7 @@
           <p:nvPr/>
         </p:nvPicPr>
         <p:blipFill>
-          <a:blip xmlns:r="http://schemas.openxmlformats.org/officeDocument/2006/relationships" xmlns:a="http://schemas.openxmlformats.org/drawingml/2006/main" r:embed="R4f9eb7324a894056"/>
+          <a:blip xmlns:r="http://schemas.openxmlformats.org/officeDocument/2006/relationships" xmlns:a="http://schemas.openxmlformats.org/drawingml/2006/main" r:embed="Rf91a60898c1e4931"/>
           <a:stretch xmlns:a="http://schemas.openxmlformats.org/drawingml/2006/main"/>
         </p:blipFill>
         <p:spPr>

</xml_diff>

<commit_message>
Complete Russian report and poster assets
</commit_message>
<xml_diff>
--- a/poster/Lapin_Vladislav_DoRA_AIRI_2026_RU.pptx
+++ b/poster/Lapin_Vladislav_DoRA_AIRI_2026_RU.pptx
@@ -2,13 +2,13 @@
 <file path=ppt/presentation.xml><?xml version="1.0" encoding="utf-8"?>
 <p:presentation xmlns:p="http://schemas.openxmlformats.org/presentationml/2006/main">
   <p:sldMasterIdLst>
-    <p:sldMasterId xmlns:r="http://schemas.openxmlformats.org/officeDocument/2006/relationships" id="2147483648" r:id="R969364674e8f4aa9"/>
+    <p:sldMasterId xmlns:r="http://schemas.openxmlformats.org/officeDocument/2006/relationships" id="2147483648" r:id="Re0937965e1704a47"/>
   </p:sldMasterIdLst>
   <p:notesMasterIdLst>
-    <p:notesMasterId xmlns:r="http://schemas.openxmlformats.org/officeDocument/2006/relationships" r:id="Ra235a33a79914086"/>
+    <p:notesMasterId xmlns:r="http://schemas.openxmlformats.org/officeDocument/2006/relationships" r:id="Rc8d9a15888b44ff4"/>
   </p:notesMasterIdLst>
   <p:sldIdLst>
-    <p:sldId xmlns:r="http://schemas.openxmlformats.org/officeDocument/2006/relationships" id="256" r:id="Ra987fbf7cc2d4081"/>
+    <p:sldId xmlns:r="http://schemas.openxmlformats.org/officeDocument/2006/relationships" id="256" r:id="R808005dfab5f4d23"/>
   </p:sldIdLst>
   <p:sldSz cx="21383625" cy="30275213"/>
   <p:notesSz cx="6858000" cy="9144000"/>
@@ -590,7 +590,7 @@
           <p:nvPr/>
         </p:nvPicPr>
         <p:blipFill>
-          <a:blip xmlns:r="http://schemas.openxmlformats.org/officeDocument/2006/relationships" xmlns:a="http://schemas.openxmlformats.org/drawingml/2006/main" r:embed="R317ad2146d864531"/>
+          <a:blip xmlns:r="http://schemas.openxmlformats.org/officeDocument/2006/relationships" xmlns:a="http://schemas.openxmlformats.org/drawingml/2006/main" r:embed="Rb5584c6ec6104ca5"/>
           <a:stretch xmlns:a="http://schemas.openxmlformats.org/drawingml/2006/main">
             <a:fillRect l="0" t="0" r="0" b="0"/>
           </a:stretch>
@@ -614,7 +614,7 @@
           <p:nvPr/>
         </p:nvPicPr>
         <p:blipFill>
-          <a:blip xmlns:r="http://schemas.openxmlformats.org/officeDocument/2006/relationships" xmlns:a="http://schemas.openxmlformats.org/drawingml/2006/main" r:embed="R67f27bce20674667"/>
+          <a:blip xmlns:r="http://schemas.openxmlformats.org/officeDocument/2006/relationships" xmlns:a="http://schemas.openxmlformats.org/drawingml/2006/main" r:embed="R9d50f269c7084e45"/>
           <a:stretch xmlns:a="http://schemas.openxmlformats.org/drawingml/2006/main">
             <a:fillRect l="0" t="0" r="0" b="0"/>
           </a:stretch>
@@ -684,7 +684,7 @@
           <p:nvPr/>
         </p:nvPicPr>
         <p:blipFill>
-          <a:blip xmlns:r="http://schemas.openxmlformats.org/officeDocument/2006/relationships" xmlns:a="http://schemas.openxmlformats.org/drawingml/2006/main" r:embed="Rde390f389e9b4f8d"/>
+          <a:blip xmlns:r="http://schemas.openxmlformats.org/officeDocument/2006/relationships" xmlns:a="http://schemas.openxmlformats.org/drawingml/2006/main" r:embed="R00c3e4ac3c25448d"/>
           <a:stretch xmlns:a="http://schemas.openxmlformats.org/drawingml/2006/main">
             <a:fillRect l="0" t="0" r="0" b="0"/>
           </a:stretch>
@@ -708,7 +708,7 @@
           <p:nvPr/>
         </p:nvPicPr>
         <p:blipFill>
-          <a:blip xmlns:r="http://schemas.openxmlformats.org/officeDocument/2006/relationships" xmlns:a="http://schemas.openxmlformats.org/drawingml/2006/main" r:embed="R7644c75b0b2149c4"/>
+          <a:blip xmlns:r="http://schemas.openxmlformats.org/officeDocument/2006/relationships" xmlns:a="http://schemas.openxmlformats.org/drawingml/2006/main" r:embed="Rc8785ea0747d4976"/>
           <a:stretch xmlns:a="http://schemas.openxmlformats.org/drawingml/2006/main">
             <a:fillRect l="0" t="0" r="0" b="0"/>
           </a:stretch>
@@ -875,7 +875,7 @@
   </p:cSld>
   <p:clrMap bg1="lt1" tx1="dk1" bg2="lt2" tx2="dk2" accent1="accent1" accent2="accent2" accent3="accent3" accent4="accent4" accent5="accent5" accent6="accent6" hlink="hlink" folHlink="folHlink"/>
   <p:sldLayoutIdLst>
-    <p:sldLayoutId xmlns:r="http://schemas.openxmlformats.org/officeDocument/2006/relationships" id="2147483649" r:id="R3ac3a0a19dd0442b"/>
+    <p:sldLayoutId xmlns:r="http://schemas.openxmlformats.org/officeDocument/2006/relationships" id="2147483649" r:id="Rc5b151b24dc54b29"/>
   </p:sldLayoutIdLst>
   <p:txStyles>
     <p:titleStyle>
@@ -1495,7 +1495,7 @@
                 <a:ea typeface="Arial"/>
                 <a:cs typeface="Arial"/>
               </a:rPr>
-              <a:t>Геометрия, бюджеты параметров и few-shot-адаптация на удержанных сидах</a:t>
+              <a:t>Геометрия, бюджеты параметров и адаптация по малой выборке на удержанных сидах</a:t>
             </a:r>
           </a:p>
         </p:txBody>
@@ -1721,7 +1721,7 @@
         <p:spPr>
           <a:xfrm xmlns:a="http://schemas.openxmlformats.org/drawingml/2006/main">
             <a:off x="11542966" y="7848600"/>
-            <a:ext cx="8328851" cy="1190625"/>
+            <a:ext cx="8328851" cy="1476375"/>
           </a:xfrm>
           <a:prstGeom xmlns:a="http://schemas.openxmlformats.org/drawingml/2006/main" prst="rect">
             <a:avLst/>
@@ -1818,7 +1818,18 @@
                 <a:ea typeface="Arial"/>
                 <a:cs typeface="Arial"/>
               </a:rPr>
-              <a:t>. Условные эффекты на фиксированных чекпоинтах; это не внешняя (независимая) репликация.</a:t>
+              <a:t>. </a:t>
+            </a:r>
+            <a:r>
+              <a:rPr sz="2400" b="0">
+                <a:solidFill>
+                  <a:srgbClr val="101820"/>
+                </a:solidFill>
+                <a:latin typeface="Arial"/>
+                <a:ea typeface="Arial"/>
+                <a:cs typeface="Arial"/>
+              </a:rPr>
+              <a:t>Внутреннее подтверждение на фиксированных чекпоинтах ≠ внешняя репликация.</a:t>
             </a:r>
           </a:p>
         </p:txBody>
@@ -2044,7 +2055,7 @@
         <p:spPr>
           <a:xfrm xmlns:a="http://schemas.openxmlformats.org/drawingml/2006/main">
             <a:off x="1509808" y="7400925"/>
-            <a:ext cx="8328851" cy="3752850"/>
+            <a:ext cx="8328851" cy="4276725"/>
           </a:xfrm>
           <a:prstGeom xmlns:a="http://schemas.openxmlformats.org/drawingml/2006/main" prst="rect">
             <a:avLst/>
@@ -2071,103 +2082,20 @@
             </a:lvl1pPr>
           </a:lstStyle>
           <a:p xmlns:a="http://schemas.openxmlformats.org/drawingml/2006/main">
-            <a:pPr marL="24" indent="-14" algn="l">
-              <a:lnSpc>
-                <a:spcPct val="108000"/>
-              </a:lnSpc>
-              <a:spcAft>
-                <a:spcPts val="7"/>
-              </a:spcAft>
-              <a:buNone/>
-              <a:defRPr sz="2100" b="0">
-                <a:solidFill>
-                  <a:srgbClr val="101820"/>
-                </a:solidFill>
-                <a:latin typeface="Arial"/>
-                <a:ea typeface="Arial"/>
-                <a:cs typeface="Arial"/>
-              </a:defRPr>
-            </a:pPr>
-            <a:r>
-              <a:rPr sz="2100" b="0">
-                <a:solidFill>
-                  <a:srgbClr val="101820"/>
-                </a:solidFill>
-                <a:latin typeface="Arial"/>
-                <a:ea typeface="Arial"/>
-                <a:cs typeface="Arial"/>
-              </a:rPr>
-              <a:t>LoRA добавляет низкоранговое обновление BA, связывая направление и норму строк. DoRA задаёт W = m ⊙ (W₀ + BA) / ‖W₀ + BA‖₂, поэтому BA управляет направлением, а m — масштабом строк.</a:t>
-            </a:r>
-          </a:p>
-          <a:p xmlns:a="http://schemas.openxmlformats.org/drawingml/2006/main">
-            <a:pPr marL="24" indent="-14" algn="l">
-              <a:lnSpc>
-                <a:spcPct val="100000"/>
-              </a:lnSpc>
-              <a:spcAft>
-                <a:spcPts val="7"/>
-              </a:spcAft>
-              <a:buNone/>
-              <a:defRPr sz="2400" b="0">
-                <a:solidFill>
-                  <a:srgbClr val="111111"/>
-                </a:solidFill>
-                <a:latin typeface="Arial"/>
-                <a:ea typeface="Arial"/>
-                <a:cs typeface="Arial"/>
-              </a:defRPr>
-            </a:pPr>
-            <a:r>
-              <a:rPr sz="2400" b="0">
-                <a:solidFill>
-                  <a:srgbClr val="111111"/>
-                </a:solidFill>
-                <a:latin typeface="Arial"/>
-                <a:ea typeface="Arial"/>
-                <a:cs typeface="Arial"/>
-              </a:rPr>
-              <a:t/>
-            </a:r>
-          </a:p>
-          <a:p xmlns:a="http://schemas.openxmlformats.org/drawingml/2006/main">
-            <a:pPr marL="24" indent="-14" algn="l">
-              <a:lnSpc>
-                <a:spcPct val="108000"/>
-              </a:lnSpc>
-              <a:spcAft>
-                <a:spcPts val="7"/>
-              </a:spcAft>
-              <a:buNone/>
-              <a:defRPr sz="2100" b="0">
-                <a:solidFill>
-                  <a:srgbClr val="101820"/>
-                </a:solidFill>
-                <a:latin typeface="Arial"/>
-                <a:ea typeface="Arial"/>
-                <a:cs typeface="Arial"/>
-              </a:defRPr>
-            </a:pPr>
-            <a:r>
-              <a:rPr sz="2100" b="1">
-                <a:solidFill>
-                  <a:srgbClr val="101820"/>
-                </a:solidFill>
-                <a:latin typeface="Arial"/>
-                <a:ea typeface="Arial"/>
-                <a:cs typeface="Arial"/>
-              </a:rPr>
+            <a:pPr algn="l"/>
+            <a:r>
+              <a:rPr sz="2400"/>
+              <a:t>LoRA добавляет низкоранговое обновление BA, связывая направление и норму строк. DoRA задаёт W = m ⊙ (W₀ + BA) / ‖W₀ + BA‖₂: BA управляет направлением, а m — масштабом строк.</a:t>
+            </a:r>
+          </a:p>
+          <a:p xmlns:a="http://schemas.openxmlformats.org/drawingml/2006/main">
+            <a:pPr algn="l"/>
+            <a:r>
+              <a:rPr sz="2400" b="1"/>
               <a:t>Исследовательский вопрос:</a:t>
             </a:r>
             <a:r>
-              <a:rPr sz="2100" b="0">
-                <a:solidFill>
-                  <a:srgbClr val="101820"/>
-                </a:solidFill>
-                <a:latin typeface="Arial"/>
-                <a:ea typeface="Arial"/>
-                <a:cs typeface="Arial"/>
-              </a:rPr>
+              <a:rPr sz="2400"/>
               <a:t> улучшает ли эта степень свободы целевую адаптацию после честного выбора, контроля бюджета параметров и негативных контролей?</a:t>
             </a:r>
           </a:p>
@@ -2361,307 +2289,54 @@
             </a:lvl1pPr>
           </a:lstStyle>
           <a:p xmlns:a="http://schemas.openxmlformats.org/drawingml/2006/main">
-            <a:pPr marL="24" indent="-14" algn="l">
-              <a:lnSpc>
-                <a:spcPct val="106000"/>
-              </a:lnSpc>
-              <a:spcAft>
-                <a:spcPts val="7"/>
-              </a:spcAft>
-              <a:buNone/>
-              <a:defRPr sz="2025" b="0">
-                <a:solidFill>
-                  <a:srgbClr val="101820"/>
-                </a:solidFill>
-                <a:latin typeface="Arial"/>
-                <a:ea typeface="Arial"/>
-                <a:cs typeface="Arial"/>
-              </a:defRPr>
-            </a:pPr>
-            <a:r>
-              <a:rPr sz="2025" b="1">
-                <a:solidFill>
-                  <a:srgbClr val="101820"/>
-                </a:solidFill>
-                <a:latin typeface="Arial"/>
-                <a:ea typeface="Arial"/>
-                <a:cs typeface="Arial"/>
-              </a:rPr>
-              <a:t>Только пилотный этап</a:t>
-            </a:r>
-            <a:r>
-              <a:rPr sz="2025" b="0">
-                <a:solidFill>
-                  <a:srgbClr val="101820"/>
-                </a:solidFill>
-                <a:latin typeface="Arial"/>
-                <a:ea typeface="Arial"/>
-                <a:cs typeface="Arial"/>
-              </a:rPr>
-              <a:t> (валидация): скорость обучения, ранняя остановка и распределение ранга.</a:t>
-            </a:r>
-          </a:p>
-          <a:p xmlns:a="http://schemas.openxmlformats.org/drawingml/2006/main">
-            <a:pPr marL="24" indent="-14" algn="l">
-              <a:lnSpc>
-                <a:spcPct val="106000"/>
-              </a:lnSpc>
-              <a:spcAft>
-                <a:spcPts val="7"/>
-              </a:spcAft>
-              <a:buNone/>
-              <a:defRPr sz="2025" b="0">
-                <a:solidFill>
-                  <a:srgbClr val="101820"/>
-                </a:solidFill>
-                <a:latin typeface="Arial"/>
-                <a:ea typeface="Arial"/>
-                <a:cs typeface="Arial"/>
-              </a:defRPr>
-            </a:pPr>
-            <a:r>
-              <a:rPr sz="2025" b="1">
-                <a:solidFill>
-                  <a:srgbClr val="101820"/>
-                </a:solidFill>
-                <a:latin typeface="Arial"/>
-                <a:ea typeface="Arial"/>
-                <a:cs typeface="Arial"/>
-              </a:rPr>
+            <a:pPr algn="l"/>
+            <a:r>
+              <a:rPr sz="2400" b="1"/>
+              <a:t>Валидация (5 пилотных сидов):</a:t>
+            </a:r>
+            <a:r>
+              <a:rPr sz="2400"/>
+              <a:t> скорость обучения, ранняя остановка, распределение ранга.</a:t>
+            </a:r>
+          </a:p>
+          <a:p xmlns:a="http://schemas.openxmlformats.org/drawingml/2006/main">
+            <a:pPr algn="l"/>
+            <a:r>
+              <a:rPr sz="2400" b="1"/>
               <a:t>Удержанные сиды:</a:t>
             </a:r>
             <a:r>
-              <a:rPr sz="2025" b="0">
-                <a:solidFill>
-                  <a:srgbClr val="101820"/>
-                </a:solidFill>
-                <a:latin typeface="Arial"/>
-                <a:ea typeface="Arial"/>
-                <a:cs typeface="Arial"/>
-              </a:rPr>
-              <a:t> </a:t>
-            </a:r>
-            <a:r>
-              <a:rPr sz="2025" b="0">
-                <a:solidFill>
-                  <a:srgbClr val="101820"/>
-                </a:solidFill>
-                <a:latin typeface="Arial"/>
-                <a:ea typeface="Arial"/>
-                <a:cs typeface="Arial"/>
-              </a:rPr>
-              <a:t>20 сидов адаптации MLP + 10 CNN; по одному фиксированному чекпоинту; 3 сдвига; </a:t>
-            </a:r>
-            <a:r>
-              <a:rPr sz="2025" b="0">
-                <a:solidFill>
-                  <a:srgbClr val="101820"/>
-                </a:solidFill>
-                <a:latin typeface="Arial"/>
-                <a:ea typeface="Arial"/>
-                <a:cs typeface="Arial"/>
-              </a:rPr>
-              <a:t>семьи сравнений (Холм): m=9 / 6 / 3</a:t>
-            </a:r>
-            <a:r>
-              <a:rPr sz="2025" b="0">
-                <a:solidFill>
-                  <a:srgbClr val="101820"/>
-                </a:solidFill>
-                <a:latin typeface="Arial"/>
-                <a:ea typeface="Arial"/>
-                <a:cs typeface="Arial"/>
-              </a:rPr>
-              <a:t> (вторичная — описательная).</a:t>
-            </a:r>
-          </a:p>
-          <a:p xmlns:a="http://schemas.openxmlformats.org/drawingml/2006/main">
-            <a:pPr marL="24" indent="-14" algn="l">
-              <a:lnSpc>
-                <a:spcPct val="106000"/>
-              </a:lnSpc>
-              <a:spcAft>
-                <a:spcPts val="7"/>
-              </a:spcAft>
-              <a:buNone/>
-              <a:defRPr sz="2025" b="0">
-                <a:solidFill>
-                  <a:srgbClr val="101820"/>
-                </a:solidFill>
-                <a:latin typeface="Arial"/>
-                <a:ea typeface="Arial"/>
-                <a:cs typeface="Arial"/>
-              </a:defRPr>
-            </a:pPr>
-            <a:r>
-              <a:rPr sz="2025" b="1">
-                <a:solidFill>
-                  <a:srgbClr val="101820"/>
-                </a:solidFill>
-                <a:latin typeface="Arial"/>
-                <a:ea typeface="Arial"/>
-                <a:cs typeface="Arial"/>
-              </a:rPr>
+              <a:rPr sz="2400"/>
+              <a:t> MLP — 20, CNN — 10; один фиксированный чекпоинт на архитектуру; три сдвига; отдельные семьи сравнений Холма m=9/6/3 (последняя — описательная).</a:t>
+            </a:r>
+          </a:p>
+          <a:p xmlns:a="http://schemas.openxmlformats.org/drawingml/2006/main">
+            <a:pPr algn="l"/>
+            <a:r>
+              <a:rPr sz="2400" b="1"/>
               <a:t>Базовые варианты:</a:t>
             </a:r>
             <a:r>
-              <a:rPr sz="2025" b="0">
-                <a:solidFill>
-                  <a:srgbClr val="101820"/>
-                </a:solidFill>
-                <a:latin typeface="Arial"/>
-                <a:ea typeface="Arial"/>
-                <a:cs typeface="Arial"/>
-              </a:rPr>
-              <a:t> замороженная модель, адаптация только величины, LoRA, </a:t>
-            </a:r>
-            <a:r>
-              <a:rPr sz="2025" b="0">
-                <a:solidFill>
-                  <a:srgbClr val="101820"/>
-                </a:solidFill>
-                <a:latin typeface="Arial"/>
-                <a:ea typeface="Arial"/>
-                <a:cs typeface="Arial"/>
-              </a:rPr>
-              <a:t>LoRA+ (фикс. B/A=16), </a:t>
-            </a:r>
-            <a:r>
-              <a:rPr sz="2025" b="0">
-                <a:solidFill>
-                  <a:srgbClr val="101820"/>
-                </a:solidFill>
-                <a:latin typeface="Arial"/>
-                <a:ea typeface="Arial"/>
-                <a:cs typeface="Arial"/>
-              </a:rPr>
-              <a:t>согласованная по бюджету параметров LoRA</a:t>
-            </a:r>
-            <a:r>
-              <a:rPr sz="2025" b="0">
-                <a:solidFill>
-                  <a:srgbClr val="101820"/>
-                </a:solidFill>
-                <a:latin typeface="Arial"/>
-                <a:ea typeface="Arial"/>
-                <a:cs typeface="Arial"/>
-              </a:rPr>
-              <a:t>, </a:t>
-            </a:r>
-            <a:r>
-              <a:rPr sz="2025" b="0">
-                <a:solidFill>
-                  <a:srgbClr val="101820"/>
-                </a:solidFill>
-                <a:latin typeface="Arial"/>
-                <a:ea typeface="Arial"/>
-                <a:cs typeface="Arial"/>
-              </a:rPr>
-              <a:t>DoRA в рамках бюджета параметров LoRA</a:t>
-            </a:r>
-            <a:r>
-              <a:rPr sz="2025" b="0">
-                <a:solidFill>
-                  <a:srgbClr val="101820"/>
-                </a:solidFill>
-                <a:latin typeface="Arial"/>
-                <a:ea typeface="Arial"/>
-                <a:cs typeface="Arial"/>
-              </a:rPr>
-              <a:t> и полное дообучение.</a:t>
-            </a:r>
-          </a:p>
-          <a:p xmlns:a="http://schemas.openxmlformats.org/drawingml/2006/main">
-            <a:pPr algn="l">
-              <a:lnSpc>
-                <a:spcPct val="106000"/>
-              </a:lnSpc>
-              <a:spcAft>
-                <a:spcPts val="0"/>
-              </a:spcAft>
-              <a:buNone/>
-              <a:defRPr sz="2025" b="0">
-                <a:solidFill>
-                  <a:srgbClr val="101820"/>
-                </a:solidFill>
-                <a:latin typeface="Arial"/>
-                <a:ea typeface="Arial"/>
-                <a:cs typeface="Arial"/>
-              </a:defRPr>
-            </a:pPr>
-            <a:r>
-              <a:rPr sz="2025" b="1">
-                <a:solidFill>
-                  <a:srgbClr val="101820"/>
-                </a:solidFill>
-                <a:latin typeface="Arial"/>
-                <a:ea typeface="Arial"/>
-                <a:cs typeface="Arial"/>
-              </a:rPr>
+              <a:rPr sz="2400"/>
+              <a:t> замороженная модель, только величина, LoRA, LoRA+ (B/A=16), согласованная по бюджету LoRA, DoRA в бюджете LoRA, полное дообучение.</a:t>
+            </a:r>
+          </a:p>
+          <a:p xmlns:a="http://schemas.openxmlformats.org/drawingml/2006/main">
+            <a:pPr algn="l"/>
+            <a:r>
+              <a:rPr sz="2400" b="1"/>
               <a:t>Устойчивость:</a:t>
             </a:r>
             <a:r>
-              <a:rPr sz="2025" b="0">
-                <a:solidFill>
-                  <a:srgbClr val="101820"/>
-                </a:solidFill>
-                <a:latin typeface="Arial"/>
-                <a:ea typeface="Arial"/>
-                <a:cs typeface="Arial"/>
-              </a:rPr>
-              <a:t> 4 вложенных режима данных; 10 синтетических целей × 5 инициализаций.</a:t>
-            </a:r>
-          </a:p>
-          <a:p xmlns:a="http://schemas.openxmlformats.org/drawingml/2006/main">
-            <a:pPr algn="l">
-              <a:lnSpc>
-                <a:spcPct val="106000"/>
-              </a:lnSpc>
-              <a:spcAft>
-                <a:spcPts val="0"/>
-              </a:spcAft>
-              <a:buNone/>
-              <a:defRPr sz="2025" b="0">
-                <a:solidFill>
-                  <a:srgbClr val="101820"/>
-                </a:solidFill>
-                <a:latin typeface="Arial"/>
-                <a:ea typeface="Arial"/>
-                <a:cs typeface="Arial"/>
-              </a:defRPr>
-            </a:pPr>
-            <a:r>
-              <a:rPr sz="2025" b="1">
-                <a:solidFill>
-                  <a:srgbClr val="101820"/>
-                </a:solidFill>
-                <a:latin typeface="Arial"/>
-                <a:ea typeface="Arial"/>
-                <a:cs typeface="Arial"/>
-              </a:rPr>
-              <a:t>1,960</a:t>
-            </a:r>
-            <a:r>
-              <a:rPr sz="2025" b="0">
-                <a:solidFill>
-                  <a:srgbClr val="101820"/>
-                </a:solidFill>
-                <a:latin typeface="Arial"/>
-                <a:ea typeface="Arial"/>
-                <a:cs typeface="Arial"/>
-              </a:rPr>
-              <a:t> сохранённых строк; </a:t>
-            </a:r>
-            <a:r>
-              <a:rPr sz="2025" b="0">
-                <a:solidFill>
-                  <a:srgbClr val="101820"/>
-                </a:solidFill>
-                <a:latin typeface="Arial"/>
-                <a:ea typeface="Arial"/>
-                <a:cs typeface="Arial"/>
-              </a:rPr>
-              <a:t>1,840 задач обучения / оптимизации.</a:t>
+              <a:rPr sz="2400"/>
+              <a:t> 4 вложенных объёма данных; 10 синтетических целей × 5 инициализаций.</a:t>
+            </a:r>
+          </a:p>
+          <a:p xmlns:a="http://schemas.openxmlformats.org/drawingml/2006/main">
+            <a:pPr algn="l"/>
+            <a:r>
+              <a:rPr sz="2400" b="1"/>
+              <a:t>1 960 строк; 1 840 задач обучения/оптимизации.</a:t>
             </a:r>
           </a:p>
         </p:txBody>
@@ -2755,7 +2430,7 @@
         <p:spPr>
           <a:xfrm xmlns:a="http://schemas.openxmlformats.org/drawingml/2006/main">
             <a:off x="1509808" y="23574375"/>
-            <a:ext cx="8328851" cy="3829050"/>
+            <a:ext cx="8328851" cy="4400550"/>
           </a:xfrm>
           <a:prstGeom xmlns:a="http://schemas.openxmlformats.org/drawingml/2006/main" prst="rect">
             <a:avLst/>
@@ -2782,219 +2457,47 @@
             </a:lvl1pPr>
           </a:lstStyle>
           <a:p xmlns:a="http://schemas.openxmlformats.org/drawingml/2006/main">
-            <a:pPr marL="24" indent="-14" algn="l">
-              <a:lnSpc>
-                <a:spcPct val="108000"/>
-              </a:lnSpc>
-              <a:spcAft>
-                <a:spcPts val="7"/>
-              </a:spcAft>
-              <a:buNone/>
-              <a:defRPr sz="2025" b="0">
-                <a:solidFill>
-                  <a:srgbClr val="101820"/>
-                </a:solidFill>
-                <a:latin typeface="Arial"/>
-                <a:ea typeface="Arial"/>
-                <a:cs typeface="Arial"/>
-              </a:defRPr>
-            </a:pPr>
-            <a:r>
-              <a:rPr sz="2025" b="1">
-                <a:solidFill>
-                  <a:srgbClr val="101820"/>
-                </a:solidFill>
-                <a:latin typeface="Arial"/>
-                <a:ea typeface="Arial"/>
-                <a:cs typeface="Arial"/>
-              </a:rPr>
+            <a:pPr algn="l"/>
+            <a:r>
+              <a:rPr sz="2400" b="1"/>
               <a:t>Контраст (MLP):</a:t>
             </a:r>
             <a:r>
-              <a:rPr sz="2025" b="0">
-                <a:solidFill>
-                  <a:srgbClr val="101820"/>
-                </a:solidFill>
-                <a:latin typeface="Arial"/>
-                <a:ea typeface="Arial"/>
-                <a:cs typeface="Arial"/>
-              </a:rPr>
+              <a:rPr sz="2400"/>
               <a:t> адаптация только величины 96.90% &gt; DoRA 95.18%.</a:t>
             </a:r>
           </a:p>
           <a:p xmlns:a="http://schemas.openxmlformats.org/drawingml/2006/main">
-            <a:pPr marL="24" indent="-14" algn="l">
-              <a:lnSpc>
-                <a:spcPct val="108000"/>
-              </a:lnSpc>
-              <a:spcAft>
-                <a:spcPts val="7"/>
-              </a:spcAft>
-              <a:buNone/>
-              <a:defRPr sz="2025" b="0">
-                <a:solidFill>
-                  <a:srgbClr val="101820"/>
-                </a:solidFill>
-                <a:latin typeface="Arial"/>
-                <a:ea typeface="Arial"/>
-                <a:cs typeface="Arial"/>
-              </a:defRPr>
-            </a:pPr>
-            <a:r>
-              <a:rPr sz="2025" b="1">
-                <a:solidFill>
-                  <a:srgbClr val="101820"/>
-                </a:solidFill>
-                <a:latin typeface="Arial"/>
-                <a:ea typeface="Arial"/>
-                <a:cs typeface="Arial"/>
-              </a:rPr>
+            <a:pPr algn="l"/>
+            <a:r>
+              <a:rPr sz="2400" b="1"/>
               <a:t>Поворот (MLP):</a:t>
             </a:r>
             <a:r>
-              <a:rPr sz="2025" b="0">
-                <a:solidFill>
-                  <a:srgbClr val="101820"/>
-                </a:solidFill>
-                <a:latin typeface="Arial"/>
-                <a:ea typeface="Arial"/>
-                <a:cs typeface="Arial"/>
-              </a:rPr>
-              <a:t> </a:t>
-            </a:r>
-            <a:r>
-              <a:rPr sz="2025" b="0">
-                <a:solidFill>
-                  <a:srgbClr val="101820"/>
-                </a:solidFill>
-                <a:latin typeface="Arial"/>
-                <a:ea typeface="Arial"/>
-                <a:cs typeface="Arial"/>
-              </a:rPr>
-              <a:t>согласованная по бюджету параметров LoRA</a:t>
-            </a:r>
-            <a:r>
-              <a:rPr sz="2025" b="0">
-                <a:solidFill>
-                  <a:srgbClr val="101820"/>
-                </a:solidFill>
-                <a:latin typeface="Arial"/>
-                <a:ea typeface="Arial"/>
-                <a:cs typeface="Arial"/>
-              </a:rPr>
-              <a:t> = DoRA = 93.89%.</a:t>
-            </a:r>
-          </a:p>
-          <a:p xmlns:a="http://schemas.openxmlformats.org/drawingml/2006/main">
-            <a:pPr marL="24" indent="-14" algn="l">
-              <a:lnSpc>
-                <a:spcPct val="108000"/>
-              </a:lnSpc>
-              <a:spcAft>
-                <a:spcPts val="7"/>
-              </a:spcAft>
-              <a:buNone/>
-              <a:defRPr sz="2025" b="0">
-                <a:solidFill>
-                  <a:srgbClr val="101820"/>
-                </a:solidFill>
-                <a:latin typeface="Arial"/>
-                <a:ea typeface="Arial"/>
-                <a:cs typeface="Arial"/>
-              </a:defRPr>
-            </a:pPr>
-            <a:r>
-              <a:rPr sz="2025" b="1">
-                <a:solidFill>
-                  <a:srgbClr val="101820"/>
-                </a:solidFill>
-                <a:latin typeface="Arial"/>
-                <a:ea typeface="Arial"/>
-                <a:cs typeface="Arial"/>
-              </a:rPr>
+              <a:rPr sz="2400"/>
+              <a:t> согласованная по бюджету параметров LoRA = DoRA = 93.89%.</a:t>
+            </a:r>
+          </a:p>
+          <a:p xmlns:a="http://schemas.openxmlformats.org/drawingml/2006/main">
+            <a:pPr algn="l"/>
+            <a:r>
+              <a:rPr sz="2400" b="1"/>
               <a:t>Смешанный сдвиг (MLP):</a:t>
             </a:r>
             <a:r>
-              <a:rPr sz="2025" b="0">
-                <a:solidFill>
-                  <a:srgbClr val="101820"/>
-                </a:solidFill>
-                <a:latin typeface="Arial"/>
-                <a:ea typeface="Arial"/>
-                <a:cs typeface="Arial"/>
-              </a:rPr>
+              <a:rPr sz="2400"/>
               <a:t> согласование бюджета параметров снижает разрыв DoRA до +0.53 п.п.; ДИ пересекает ноль.</a:t>
             </a:r>
           </a:p>
           <a:p xmlns:a="http://schemas.openxmlformats.org/drawingml/2006/main">
-            <a:pPr marL="24" indent="-14" algn="l">
-              <a:lnSpc>
-                <a:spcPct val="98000"/>
-              </a:lnSpc>
-              <a:spcAft>
-                <a:spcPts val="7"/>
-              </a:spcAft>
-              <a:buNone/>
-              <a:defRPr sz="2325" b="0">
-                <a:solidFill>
-                  <a:srgbClr val="111111"/>
-                </a:solidFill>
-                <a:latin typeface="Arial"/>
-                <a:ea typeface="Arial"/>
-                <a:cs typeface="Arial"/>
-              </a:defRPr>
-            </a:pPr>
-            <a:r>
-              <a:rPr sz="2325" b="0">
-                <a:solidFill>
-                  <a:srgbClr val="111111"/>
-                </a:solidFill>
-                <a:latin typeface="Arial"/>
-                <a:ea typeface="Arial"/>
-                <a:cs typeface="Arial"/>
-              </a:rPr>
-              <a:t/>
-            </a:r>
-          </a:p>
-          <a:p xmlns:a="http://schemas.openxmlformats.org/drawingml/2006/main">
-            <a:pPr marL="24" indent="-14" algn="l">
-              <a:lnSpc>
-                <a:spcPct val="108000"/>
-              </a:lnSpc>
-              <a:spcAft>
-                <a:spcPts val="7"/>
-              </a:spcAft>
-              <a:buNone/>
-              <a:defRPr sz="2025" b="0">
-                <a:solidFill>
-                  <a:srgbClr val="101820"/>
-                </a:solidFill>
-                <a:latin typeface="Arial"/>
-                <a:ea typeface="Arial"/>
-                <a:cs typeface="Arial"/>
-              </a:defRPr>
-            </a:pPr>
-            <a:r>
-              <a:rPr sz="2025" b="1">
-                <a:solidFill>
-                  <a:srgbClr val="101820"/>
-                </a:solidFill>
-                <a:latin typeface="Arial"/>
-                <a:ea typeface="Arial"/>
-                <a:cs typeface="Arial"/>
-              </a:rPr>
+            <a:pPr algn="l"/>
+            <a:r>
+              <a:rPr sz="2400" b="1"/>
               <a:t>Рамки:</a:t>
             </a:r>
             <a:r>
-              <a:rPr sz="2025" b="0">
-                <a:solidFill>
-                  <a:srgbClr val="101820"/>
-                </a:solidFill>
-                <a:latin typeface="Arial"/>
-                <a:ea typeface="Arial"/>
-                <a:cs typeface="Arial"/>
-              </a:rPr>
-              <a:t> Digits, одна фиксированная предобученная база на архитектуру и одно целевое разбиение, уже использованное в разведочной работе. Это контролируемое исследование механизма, а не бенчмарк уровня больших языковых моделей (LLM).</a:t>
+              <a:rPr sz="2400"/>
+              <a:t> Digits; один фиксированный предобученный чекпоинт на архитектуру; одно целевое разбиение, уже использованное на разведочном этапе. Это контролируемое исследование механизма, не LLM-бенчмарк.</a:t>
             </a:r>
           </a:p>
         </p:txBody>
@@ -3088,7 +2591,7 @@
         <p:spPr>
           <a:xfrm xmlns:a="http://schemas.openxmlformats.org/drawingml/2006/main">
             <a:off x="11540395" y="23955375"/>
-            <a:ext cx="8328851" cy="3495675"/>
+            <a:ext cx="8328851" cy="4162425"/>
           </a:xfrm>
           <a:prstGeom xmlns:a="http://schemas.openxmlformats.org/drawingml/2006/main" prst="rect">
             <a:avLst/>
@@ -3115,354 +2618,63 @@
             </a:lvl1pPr>
           </a:lstStyle>
           <a:p xmlns:a="http://schemas.openxmlformats.org/drawingml/2006/main">
-            <a:pPr marL="24" indent="-14" algn="l">
-              <a:lnSpc>
-                <a:spcPct val="102000"/>
-              </a:lnSpc>
-              <a:spcAft>
-                <a:spcPts val="6"/>
-              </a:spcAft>
-              <a:buNone/>
-              <a:defRPr sz="2100">
-                <a:solidFill>
-                  <a:srgbClr val="101820"/>
-                </a:solidFill>
-                <a:latin typeface="Arial"/>
-                <a:ea typeface="Arial"/>
-                <a:cs typeface="Arial"/>
-              </a:defRPr>
-            </a:pPr>
-            <a:r>
-              <a:rPr sz="2100">
-                <a:solidFill>
-                  <a:srgbClr val="101820"/>
-                </a:solidFill>
-                <a:latin typeface="Arial"/>
-                <a:ea typeface="Arial"/>
-                <a:cs typeface="Arial"/>
-              </a:rPr>
+            <a:pPr algn="l"/>
+            <a:r>
+              <a:rPr sz="2400"/>
               <a:t>- </a:t>
             </a:r>
             <a:r>
-              <a:rPr sz="2100" b="1">
-                <a:solidFill>
-                  <a:srgbClr val="101820"/>
-                </a:solidFill>
-                <a:latin typeface="Arial"/>
-                <a:ea typeface="Arial"/>
-                <a:cs typeface="Arial"/>
-              </a:rPr>
+              <a:rPr sz="2400" b="1"/>
               <a:t>Смешанный сдвиг:</a:t>
             </a:r>
             <a:r>
-              <a:rPr sz="2100">
-                <a:solidFill>
-                  <a:srgbClr val="101820"/>
-                </a:solidFill>
-                <a:latin typeface="Arial"/>
-                <a:ea typeface="Arial"/>
-                <a:cs typeface="Arial"/>
-              </a:rPr>
-              <a:t> DoRA достигает 75.22% (MLP) и 80.53% (CNN), близко к полному дообучению (75.17%, 80.67%), при </a:t>
-            </a:r>
-            <a:r>
-              <a:rPr sz="2100">
-                <a:solidFill>
-                  <a:srgbClr val="101820"/>
-                </a:solidFill>
-                <a:latin typeface="Arial"/>
-                <a:ea typeface="Arial"/>
-                <a:cs typeface="Arial"/>
-              </a:rPr>
-              <a:t>≈12–15%</a:t>
-            </a:r>
-            <a:r>
-              <a:rPr sz="2100">
-                <a:solidFill>
-                  <a:srgbClr val="101820"/>
-                </a:solidFill>
-                <a:latin typeface="Arial"/>
-                <a:ea typeface="Arial"/>
-                <a:cs typeface="Arial"/>
-              </a:rPr>
-              <a:t> обучаемых параметров.</a:t>
-            </a:r>
-          </a:p>
-          <a:p xmlns:a="http://schemas.openxmlformats.org/drawingml/2006/main">
-            <a:pPr marL="24" indent="-14" algn="l">
-              <a:lnSpc>
-                <a:spcPct val="102000"/>
-              </a:lnSpc>
-              <a:spcAft>
-                <a:spcPts val="6"/>
-              </a:spcAft>
-              <a:buNone/>
-              <a:defRPr sz="2100">
-                <a:solidFill>
-                  <a:srgbClr val="101820"/>
-                </a:solidFill>
-                <a:latin typeface="Arial"/>
-                <a:ea typeface="Arial"/>
-                <a:cs typeface="Arial"/>
-              </a:defRPr>
-            </a:pPr>
-            <a:r>
-              <a:rPr sz="2100">
-                <a:solidFill>
-                  <a:srgbClr val="101820"/>
-                </a:solidFill>
-                <a:latin typeface="Arial"/>
-                <a:ea typeface="Arial"/>
-                <a:cs typeface="Arial"/>
-              </a:rPr>
+              <a:rPr sz="2400"/>
+              <a:t> DoRA достигает 75.22% (MLP) и 80.53% (CNN), близко к полному дообучению (75.17%, 80.67%), при ≈12–15% обучаемых параметров.</a:t>
+            </a:r>
+          </a:p>
+          <a:p xmlns:a="http://schemas.openxmlformats.org/drawingml/2006/main">
+            <a:pPr algn="l"/>
+            <a:r>
+              <a:rPr sz="2400"/>
               <a:t>- </a:t>
             </a:r>
             <a:r>
-              <a:rPr sz="2100" b="1">
-                <a:solidFill>
-                  <a:srgbClr val="101820"/>
-                </a:solidFill>
-                <a:latin typeface="Arial"/>
-                <a:ea typeface="Arial"/>
-                <a:cs typeface="Arial"/>
-              </a:rPr>
-              <a:t>Более справедливые базовые варианты:</a:t>
-            </a:r>
-            <a:r>
-              <a:rPr sz="2100">
-                <a:solidFill>
-                  <a:srgbClr val="101820"/>
-                </a:solidFill>
-                <a:latin typeface="Arial"/>
-                <a:ea typeface="Arial"/>
-                <a:cs typeface="Arial"/>
-              </a:rPr>
-              <a:t> </a:t>
-            </a:r>
-            <a:r>
-              <a:rPr sz="2100">
-                <a:solidFill>
-                  <a:srgbClr val="101820"/>
-                </a:solidFill>
-                <a:latin typeface="Arial"/>
-                <a:ea typeface="Arial"/>
-                <a:cs typeface="Arial"/>
-              </a:rPr>
-              <a:t>согласованная по бюджету параметров LoRA</a:t>
-            </a:r>
-            <a:r>
-              <a:rPr sz="2100">
-                <a:solidFill>
-                  <a:srgbClr val="101820"/>
-                </a:solidFill>
-                <a:latin typeface="Arial"/>
-                <a:ea typeface="Arial"/>
-                <a:cs typeface="Arial"/>
-              </a:rPr>
-              <a:t> оставляет +0.53 п.п.; </a:t>
-            </a:r>
-            <a:r>
-              <a:rPr sz="2100">
-                <a:solidFill>
-                  <a:srgbClr val="101820"/>
-                </a:solidFill>
-                <a:latin typeface="Arial"/>
-                <a:ea typeface="Arial"/>
-                <a:cs typeface="Arial"/>
-              </a:rPr>
-              <a:t>для DoRA−LoRA+ p с поправкой Холма = 0.050935 (&gt; 0.05)</a:t>
-            </a:r>
-            <a:r>
-              <a:rPr sz="2100">
-                <a:solidFill>
-                  <a:srgbClr val="101820"/>
-                </a:solidFill>
-                <a:latin typeface="Arial"/>
-                <a:ea typeface="Arial"/>
-                <a:cs typeface="Arial"/>
-              </a:rPr>
-              <a:t>; </a:t>
-            </a:r>
-            <a:r>
-              <a:rPr sz="2100">
-                <a:solidFill>
-                  <a:srgbClr val="101820"/>
-                </a:solidFill>
-                <a:latin typeface="Arial"/>
-                <a:ea typeface="Arial"/>
-                <a:cs typeface="Arial"/>
-              </a:rPr>
-              <a:t>DoRA в рамках бюджета параметров LoRA: +0.82 п.п.</a:t>
-            </a:r>
-            <a:r>
-              <a:rPr sz="2100">
-                <a:solidFill>
-                  <a:srgbClr val="101820"/>
-                </a:solidFill>
-                <a:latin typeface="Arial"/>
-                <a:ea typeface="Arial"/>
-                <a:cs typeface="Arial"/>
-              </a:rPr>
-              <a:t> (p с поправкой Холма во вторичной семье сравнений = 0.347089)</a:t>
-            </a:r>
-            <a:r>
-              <a:rPr sz="2100">
-                <a:solidFill>
-                  <a:srgbClr val="101820"/>
-                </a:solidFill>
-                <a:latin typeface="Arial"/>
-                <a:ea typeface="Arial"/>
-                <a:cs typeface="Arial"/>
-              </a:rPr>
-              <a:t>.</a:t>
-            </a:r>
-          </a:p>
-          <a:p xmlns:a="http://schemas.openxmlformats.org/drawingml/2006/main">
-            <a:pPr marL="24" indent="-14" algn="l">
-              <a:lnSpc>
-                <a:spcPct val="102000"/>
-              </a:lnSpc>
-              <a:spcAft>
-                <a:spcPts val="6"/>
-              </a:spcAft>
-              <a:buNone/>
-              <a:defRPr sz="2100">
-                <a:solidFill>
-                  <a:srgbClr val="101820"/>
-                </a:solidFill>
-                <a:latin typeface="Arial"/>
-                <a:ea typeface="Arial"/>
-                <a:cs typeface="Arial"/>
-              </a:defRPr>
-            </a:pPr>
-            <a:r>
-              <a:rPr sz="2100">
-                <a:solidFill>
-                  <a:srgbClr val="101820"/>
-                </a:solidFill>
-                <a:latin typeface="Arial"/>
-                <a:ea typeface="Arial"/>
-                <a:cs typeface="Arial"/>
-              </a:rPr>
+              <a:rPr sz="2400" b="1"/>
+              <a:t>Усиленные базовые варианты:</a:t>
+            </a:r>
+            <a:r>
+              <a:rPr sz="2400"/>
+              <a:t> согласованная по бюджету LoRA оставляет +0.53 п.п.; DoRA−LoRA+: p Холма=0.050935; DoRA в бюджете LoRA: +0.82 п.п. (вторичная семья: p Холма=0.347089).</a:t>
+            </a:r>
+          </a:p>
+          <a:p xmlns:a="http://schemas.openxmlformats.org/drawingml/2006/main">
+            <a:pPr algn="l"/>
+            <a:r>
+              <a:rPr sz="2400"/>
               <a:t>- </a:t>
             </a:r>
             <a:r>
-              <a:rPr sz="2100" b="1">
-                <a:solidFill>
-                  <a:srgbClr val="101820"/>
-                </a:solidFill>
-                <a:latin typeface="Arial"/>
-                <a:ea typeface="Arial"/>
-                <a:cs typeface="Arial"/>
-              </a:rPr>
-              <a:t>Синтетическая диагностика (</a:t>
-            </a:r>
-            <a:r>
-              <a:rPr sz="2100" b="1">
-                <a:solidFill>
-                  <a:srgbClr val="101820"/>
-                </a:solidFill>
-                <a:latin typeface="Arial"/>
-                <a:ea typeface="Arial"/>
-                <a:cs typeface="Arial"/>
-              </a:rPr>
-              <a:t>γ=0.8</a:t>
-            </a:r>
-            <a:r>
-              <a:rPr sz="2100" b="1">
-                <a:solidFill>
-                  <a:srgbClr val="101820"/>
-                </a:solidFill>
-                <a:latin typeface="Arial"/>
-                <a:ea typeface="Arial"/>
-                <a:cs typeface="Arial"/>
-              </a:rPr>
-              <a:t>):</a:t>
-            </a:r>
-            <a:r>
-              <a:rPr sz="2100">
-                <a:solidFill>
-                  <a:srgbClr val="101820"/>
-                </a:solidFill>
-                <a:latin typeface="Arial"/>
-                <a:ea typeface="Arial"/>
-                <a:cs typeface="Arial"/>
-              </a:rPr>
-              <a:t> DoRA представляет цель точно; 44/50 запусков достигают ошибки &lt;10^-3. </a:t>
-            </a:r>
-            <a:r>
-              <a:rPr sz="2100">
-                <a:solidFill>
-                  <a:srgbClr val="101820"/>
-                </a:solidFill>
-                <a:latin typeface="Arial"/>
-                <a:ea typeface="Arial"/>
-                <a:cs typeface="Arial"/>
-              </a:rPr>
-              <a:t>Средняя ошибка оракула LoRA — 0.289</a:t>
-            </a:r>
-            <a:r>
-              <a:rPr sz="2100">
-                <a:solidFill>
-                  <a:srgbClr val="101820"/>
-                </a:solidFill>
-                <a:latin typeface="Arial"/>
-                <a:ea typeface="Arial"/>
-                <a:cs typeface="Arial"/>
-              </a:rPr>
-              <a:t>.</a:t>
-            </a:r>
-          </a:p>
-          <a:p xmlns:a="http://schemas.openxmlformats.org/drawingml/2006/main">
-            <a:pPr marL="24" indent="-14" algn="l">
-              <a:lnSpc>
-                <a:spcPct val="102000"/>
-              </a:lnSpc>
-              <a:spcAft>
-                <a:spcPts val="0"/>
-              </a:spcAft>
-              <a:buNone/>
-              <a:defRPr sz="2100">
-                <a:solidFill>
-                  <a:srgbClr val="101820"/>
-                </a:solidFill>
-                <a:latin typeface="Arial"/>
-                <a:ea typeface="Arial"/>
-                <a:cs typeface="Arial"/>
-              </a:defRPr>
-            </a:pPr>
-            <a:r>
-              <a:rPr sz="2100">
-                <a:solidFill>
-                  <a:srgbClr val="101820"/>
-                </a:solidFill>
-                <a:latin typeface="Arial"/>
-                <a:ea typeface="Arial"/>
-                <a:cs typeface="Arial"/>
-              </a:rPr>
+              <a:rPr sz="2400" b="1"/>
+              <a:t>Синтетическая диагностика (γ=0.8):</a:t>
+            </a:r>
+            <a:r>
+              <a:rPr sz="2400"/>
+              <a:t> DoRA точно представляет цель; 44/50 запусков достигают ошибки &lt;10^-3; средняя ошибка оракула LoRA — 0.289.</a:t>
+            </a:r>
+          </a:p>
+          <a:p xmlns:a="http://schemas.openxmlformats.org/drawingml/2006/main">
+            <a:pPr algn="l"/>
+            <a:r>
+              <a:rPr sz="2400"/>
               <a:t>- </a:t>
             </a:r>
             <a:r>
-              <a:rPr sz="2100" b="1">
-                <a:solidFill>
-                  <a:srgbClr val="101820"/>
-                </a:solidFill>
-                <a:latin typeface="Arial"/>
-                <a:ea typeface="Arial"/>
-                <a:cs typeface="Arial"/>
-              </a:rPr>
+              <a:rPr sz="2400" b="1"/>
               <a:t>Следующий тест:</a:t>
             </a:r>
             <a:r>
-              <a:rPr sz="2100">
-                <a:solidFill>
-                  <a:srgbClr val="101820"/>
-                </a:solidFill>
-                <a:latin typeface="Arial"/>
-                <a:ea typeface="Arial"/>
-                <a:cs typeface="Arial"/>
-              </a:rPr>
-              <a:t> неоднородный дрейф норм строк с сохранением контролей LoRA и адаптации только величины.</a:t>
+              <a:rPr sz="2400"/>
+              <a:t> неоднородный дрейф норм строк с контролями LoRA и адаптации только величины.</a:t>
             </a:r>
           </a:p>
         </p:txBody>
@@ -4060,7 +3272,7 @@
                 <a:latin typeface="Arial"/>
                 <a:ea typeface="Arial"/>
                 <a:cs typeface="Arial"/>
-                <a:hlinkClick xmlns:r="http://schemas.openxmlformats.org/officeDocument/2006/relationships" r:id="R71bf5d17eeba4a4f"/>
+                <a:hlinkClick xmlns:r="http://schemas.openxmlformats.org/officeDocument/2006/relationships" r:id="Raba511205f4b4c00"/>
               </a:rPr>
               <a:t>ПРИВАТНАЯ ССЫЛКА</a:t>
             </a:r>
@@ -4413,7 +3625,7 @@
       </p:sp>
       <p:cxnSp>
         <p:nvCxnSpPr>
-          <p:cNvPr id="497" name=""/>
+          <p:cNvPr id="579" name=""/>
           <p:cNvCxnSpPr>
             <a:stCxn xmlns:a="http://schemas.openxmlformats.org/drawingml/2006/main" id="40" idx="3"/>
             <a:endCxn xmlns:a="http://schemas.openxmlformats.org/drawingml/2006/main" id="41" idx="1"/>
@@ -4439,7 +3651,7 @@
       </p:cxnSp>
       <p:cxnSp>
         <p:nvCxnSpPr>
-          <p:cNvPr id="498" name=""/>
+          <p:cNvPr id="580" name=""/>
           <p:cNvCxnSpPr>
             <a:stCxn xmlns:a="http://schemas.openxmlformats.org/drawingml/2006/main" id="41" idx="3"/>
             <a:endCxn xmlns:a="http://schemas.openxmlformats.org/drawingml/2006/main" id="42" idx="1"/>
@@ -4737,7 +3949,7 @@
       </p:sp>
       <p:cxnSp>
         <p:nvCxnSpPr>
-          <p:cNvPr id="503" name=""/>
+          <p:cNvPr id="585" name=""/>
           <p:cNvCxnSpPr>
             <a:stCxn xmlns:a="http://schemas.openxmlformats.org/drawingml/2006/main" id="45" idx="3"/>
             <a:endCxn xmlns:a="http://schemas.openxmlformats.org/drawingml/2006/main" id="46" idx="1"/>
@@ -4763,7 +3975,7 @@
       </p:cxnSp>
       <p:cxnSp>
         <p:nvCxnSpPr>
-          <p:cNvPr id="504" name=""/>
+          <p:cNvPr id="586" name=""/>
           <p:cNvCxnSpPr>
             <a:stCxn xmlns:a="http://schemas.openxmlformats.org/drawingml/2006/main" id="46" idx="3"/>
             <a:endCxn xmlns:a="http://schemas.openxmlformats.org/drawingml/2006/main" id="47" idx="1"/>
@@ -4789,7 +4001,7 @@
       </p:cxnSp>
       <p:cxnSp>
         <p:nvCxnSpPr>
-          <p:cNvPr id="505" name=""/>
+          <p:cNvPr id="587" name=""/>
           <p:cNvCxnSpPr>
             <a:stCxn xmlns:a="http://schemas.openxmlformats.org/drawingml/2006/main" id="47" idx="3"/>
             <a:endCxn xmlns:a="http://schemas.openxmlformats.org/drawingml/2006/main" id="48" idx="1"/>
@@ -5025,19 +4237,19 @@
       </p:sp>
       <p:pic>
         <p:nvPicPr>
-          <p:cNvPr id="509" name=""/>
+          <p:cNvPr id="591" name=""/>
           <p:cNvPicPr>
             <a:picLocks xmlns:a="http://schemas.openxmlformats.org/drawingml/2006/main" noChangeAspect="1"/>
           </p:cNvPicPr>
           <p:nvPr/>
         </p:nvPicPr>
         <p:blipFill>
-          <a:blip xmlns:r="http://schemas.openxmlformats.org/officeDocument/2006/relationships" xmlns:a="http://schemas.openxmlformats.org/drawingml/2006/main" r:embed="Rf3f9f6ccce664a1c"/>
+          <a:blip xmlns:r="http://schemas.openxmlformats.org/officeDocument/2006/relationships" xmlns:a="http://schemas.openxmlformats.org/drawingml/2006/main" r:embed="R1b89b32818df47a5"/>
           <a:stretch xmlns:a="http://schemas.openxmlformats.org/drawingml/2006/main"/>
         </p:blipFill>
         <p:spPr>
           <a:xfrm xmlns:a="http://schemas.openxmlformats.org/drawingml/2006/main" flipH="0" flipV="0">
-            <a:off x="11540395" y="9240089"/>
+            <a:off x="11540395" y="9573464"/>
             <a:ext cx="8328851" cy="12552272"/>
           </a:xfrm>
           <a:prstGeom xmlns:a="http://schemas.openxmlformats.org/drawingml/2006/main" prst="rect">
@@ -5047,14 +4259,14 @@
       </p:pic>
       <p:pic>
         <p:nvPicPr>
-          <p:cNvPr id="510" name=""/>
+          <p:cNvPr id="592" name=""/>
           <p:cNvPicPr>
             <a:picLocks xmlns:a="http://schemas.openxmlformats.org/drawingml/2006/main" noChangeAspect="1"/>
           </p:cNvPicPr>
           <p:nvPr/>
         </p:nvPicPr>
         <p:blipFill>
-          <a:blip xmlns:r="http://schemas.openxmlformats.org/officeDocument/2006/relationships" xmlns:a="http://schemas.openxmlformats.org/drawingml/2006/main" r:embed="Rf91a60898c1e4931"/>
+          <a:blip xmlns:r="http://schemas.openxmlformats.org/officeDocument/2006/relationships" xmlns:a="http://schemas.openxmlformats.org/drawingml/2006/main" r:embed="Reabbc0b71deb4a47"/>
           <a:stretch xmlns:a="http://schemas.openxmlformats.org/drawingml/2006/main"/>
         </p:blipFill>
         <p:spPr>

</xml_diff>

<commit_message>
Unify Russian capacity terminology
</commit_message>
<xml_diff>
--- a/poster/Lapin_Vladislav_DoRA_AIRI_2026_RU.pptx
+++ b/poster/Lapin_Vladislav_DoRA_AIRI_2026_RU.pptx
@@ -2,13 +2,13 @@
 <file path=ppt/presentation.xml><?xml version="1.0" encoding="utf-8"?>
 <p:presentation xmlns:p="http://schemas.openxmlformats.org/presentationml/2006/main">
   <p:sldMasterIdLst>
-    <p:sldMasterId xmlns:r="http://schemas.openxmlformats.org/officeDocument/2006/relationships" id="2147483648" r:id="Re0937965e1704a47"/>
+    <p:sldMasterId xmlns:r="http://schemas.openxmlformats.org/officeDocument/2006/relationships" id="2147483648" r:id="R5bce204c482a4c46"/>
   </p:sldMasterIdLst>
   <p:notesMasterIdLst>
-    <p:notesMasterId xmlns:r="http://schemas.openxmlformats.org/officeDocument/2006/relationships" r:id="Rc8d9a15888b44ff4"/>
+    <p:notesMasterId xmlns:r="http://schemas.openxmlformats.org/officeDocument/2006/relationships" r:id="R199c155464f34c90"/>
   </p:notesMasterIdLst>
   <p:sldIdLst>
-    <p:sldId xmlns:r="http://schemas.openxmlformats.org/officeDocument/2006/relationships" id="256" r:id="R808005dfab5f4d23"/>
+    <p:sldId xmlns:r="http://schemas.openxmlformats.org/officeDocument/2006/relationships" id="256" r:id="Re31bef5004af48cf"/>
   </p:sldIdLst>
   <p:sldSz cx="21383625" cy="30275213"/>
   <p:notesSz cx="6858000" cy="9144000"/>
@@ -590,7 +590,7 @@
           <p:nvPr/>
         </p:nvPicPr>
         <p:blipFill>
-          <a:blip xmlns:r="http://schemas.openxmlformats.org/officeDocument/2006/relationships" xmlns:a="http://schemas.openxmlformats.org/drawingml/2006/main" r:embed="Rb5584c6ec6104ca5"/>
+          <a:blip xmlns:r="http://schemas.openxmlformats.org/officeDocument/2006/relationships" xmlns:a="http://schemas.openxmlformats.org/drawingml/2006/main" r:embed="R86ff61c087cc495a"/>
           <a:stretch xmlns:a="http://schemas.openxmlformats.org/drawingml/2006/main">
             <a:fillRect l="0" t="0" r="0" b="0"/>
           </a:stretch>
@@ -614,7 +614,7 @@
           <p:nvPr/>
         </p:nvPicPr>
         <p:blipFill>
-          <a:blip xmlns:r="http://schemas.openxmlformats.org/officeDocument/2006/relationships" xmlns:a="http://schemas.openxmlformats.org/drawingml/2006/main" r:embed="R9d50f269c7084e45"/>
+          <a:blip xmlns:r="http://schemas.openxmlformats.org/officeDocument/2006/relationships" xmlns:a="http://schemas.openxmlformats.org/drawingml/2006/main" r:embed="Rf6b72a32821b497e"/>
           <a:stretch xmlns:a="http://schemas.openxmlformats.org/drawingml/2006/main">
             <a:fillRect l="0" t="0" r="0" b="0"/>
           </a:stretch>
@@ -684,7 +684,7 @@
           <p:nvPr/>
         </p:nvPicPr>
         <p:blipFill>
-          <a:blip xmlns:r="http://schemas.openxmlformats.org/officeDocument/2006/relationships" xmlns:a="http://schemas.openxmlformats.org/drawingml/2006/main" r:embed="R00c3e4ac3c25448d"/>
+          <a:blip xmlns:r="http://schemas.openxmlformats.org/officeDocument/2006/relationships" xmlns:a="http://schemas.openxmlformats.org/drawingml/2006/main" r:embed="Rdd7874fbeaf14b07"/>
           <a:stretch xmlns:a="http://schemas.openxmlformats.org/drawingml/2006/main">
             <a:fillRect l="0" t="0" r="0" b="0"/>
           </a:stretch>
@@ -708,7 +708,7 @@
           <p:nvPr/>
         </p:nvPicPr>
         <p:blipFill>
-          <a:blip xmlns:r="http://schemas.openxmlformats.org/officeDocument/2006/relationships" xmlns:a="http://schemas.openxmlformats.org/drawingml/2006/main" r:embed="Rc8785ea0747d4976"/>
+          <a:blip xmlns:r="http://schemas.openxmlformats.org/officeDocument/2006/relationships" xmlns:a="http://schemas.openxmlformats.org/drawingml/2006/main" r:embed="R43a260f876bb4d15"/>
           <a:stretch xmlns:a="http://schemas.openxmlformats.org/drawingml/2006/main">
             <a:fillRect l="0" t="0" r="0" b="0"/>
           </a:stretch>
@@ -875,7 +875,7 @@
   </p:cSld>
   <p:clrMap bg1="lt1" tx1="dk1" bg2="lt2" tx2="dk2" accent1="accent1" accent2="accent2" accent3="accent3" accent4="accent4" accent5="accent5" accent6="accent6" hlink="hlink" folHlink="folHlink"/>
   <p:sldLayoutIdLst>
-    <p:sldLayoutId xmlns:r="http://schemas.openxmlformats.org/officeDocument/2006/relationships" id="2147483649" r:id="Rc5b151b24dc54b29"/>
+    <p:sldLayoutId xmlns:r="http://schemas.openxmlformats.org/officeDocument/2006/relationships" id="2147483649" r:id="Rf741244d75ca4936"/>
   </p:sldLayoutIdLst>
   <p:txStyles>
     <p:titleStyle>
@@ -3272,7 +3272,7 @@
                 <a:latin typeface="Arial"/>
                 <a:ea typeface="Arial"/>
                 <a:cs typeface="Arial"/>
-                <a:hlinkClick xmlns:r="http://schemas.openxmlformats.org/officeDocument/2006/relationships" r:id="Raba511205f4b4c00"/>
+                <a:hlinkClick xmlns:r="http://schemas.openxmlformats.org/officeDocument/2006/relationships" r:id="R5b57fb4092694945"/>
               </a:rPr>
               <a:t>ПРИВАТНАЯ ССЫЛКА</a:t>
             </a:r>
@@ -4244,7 +4244,7 @@
           <p:nvPr/>
         </p:nvPicPr>
         <p:blipFill>
-          <a:blip xmlns:r="http://schemas.openxmlformats.org/officeDocument/2006/relationships" xmlns:a="http://schemas.openxmlformats.org/drawingml/2006/main" r:embed="R1b89b32818df47a5"/>
+          <a:blip xmlns:r="http://schemas.openxmlformats.org/officeDocument/2006/relationships" xmlns:a="http://schemas.openxmlformats.org/drawingml/2006/main" r:embed="Re90ecb40dd8549ea"/>
           <a:stretch xmlns:a="http://schemas.openxmlformats.org/drawingml/2006/main"/>
         </p:blipFill>
         <p:spPr>
@@ -4266,7 +4266,7 @@
           <p:nvPr/>
         </p:nvPicPr>
         <p:blipFill>
-          <a:blip xmlns:r="http://schemas.openxmlformats.org/officeDocument/2006/relationships" xmlns:a="http://schemas.openxmlformats.org/drawingml/2006/main" r:embed="Reabbc0b71deb4a47"/>
+          <a:blip xmlns:r="http://schemas.openxmlformats.org/officeDocument/2006/relationships" xmlns:a="http://schemas.openxmlformats.org/drawingml/2006/main" r:embed="R7201ef6f47354cdb"/>
           <a:stretch xmlns:a="http://schemas.openxmlformats.org/drawingml/2006/main"/>
         </p:blipFill>
         <p:spPr>

</xml_diff>

<commit_message>
Finish Russian terminology and poster QA
</commit_message>
<xml_diff>
--- a/poster/Lapin_Vladislav_DoRA_AIRI_2026_RU.pptx
+++ b/poster/Lapin_Vladislav_DoRA_AIRI_2026_RU.pptx
@@ -2,13 +2,13 @@
 <file path=ppt/presentation.xml><?xml version="1.0" encoding="utf-8"?>
 <p:presentation xmlns:p="http://schemas.openxmlformats.org/presentationml/2006/main">
   <p:sldMasterIdLst>
-    <p:sldMasterId xmlns:r="http://schemas.openxmlformats.org/officeDocument/2006/relationships" id="2147483648" r:id="R5bce204c482a4c46"/>
+    <p:sldMasterId xmlns:r="http://schemas.openxmlformats.org/officeDocument/2006/relationships" id="2147483648" r:id="Re89fa6d68d2d4b7c"/>
   </p:sldMasterIdLst>
   <p:notesMasterIdLst>
-    <p:notesMasterId xmlns:r="http://schemas.openxmlformats.org/officeDocument/2006/relationships" r:id="R199c155464f34c90"/>
+    <p:notesMasterId xmlns:r="http://schemas.openxmlformats.org/officeDocument/2006/relationships" r:id="R35c344bf9bd3461c"/>
   </p:notesMasterIdLst>
   <p:sldIdLst>
-    <p:sldId xmlns:r="http://schemas.openxmlformats.org/officeDocument/2006/relationships" id="256" r:id="Re31bef5004af48cf"/>
+    <p:sldId xmlns:r="http://schemas.openxmlformats.org/officeDocument/2006/relationships" id="256" r:id="R62c8749e3d1b446d"/>
   </p:sldIdLst>
   <p:sldSz cx="21383625" cy="30275213"/>
   <p:notesSz cx="6858000" cy="9144000"/>
@@ -590,7 +590,7 @@
           <p:nvPr/>
         </p:nvPicPr>
         <p:blipFill>
-          <a:blip xmlns:r="http://schemas.openxmlformats.org/officeDocument/2006/relationships" xmlns:a="http://schemas.openxmlformats.org/drawingml/2006/main" r:embed="R86ff61c087cc495a"/>
+          <a:blip xmlns:r="http://schemas.openxmlformats.org/officeDocument/2006/relationships" xmlns:a="http://schemas.openxmlformats.org/drawingml/2006/main" r:embed="Re7f4363ce42c4c04"/>
           <a:stretch xmlns:a="http://schemas.openxmlformats.org/drawingml/2006/main">
             <a:fillRect l="0" t="0" r="0" b="0"/>
           </a:stretch>
@@ -614,7 +614,7 @@
           <p:nvPr/>
         </p:nvPicPr>
         <p:blipFill>
-          <a:blip xmlns:r="http://schemas.openxmlformats.org/officeDocument/2006/relationships" xmlns:a="http://schemas.openxmlformats.org/drawingml/2006/main" r:embed="Rf6b72a32821b497e"/>
+          <a:blip xmlns:r="http://schemas.openxmlformats.org/officeDocument/2006/relationships" xmlns:a="http://schemas.openxmlformats.org/drawingml/2006/main" r:embed="Rb41ce93e6ccb4a86"/>
           <a:stretch xmlns:a="http://schemas.openxmlformats.org/drawingml/2006/main">
             <a:fillRect l="0" t="0" r="0" b="0"/>
           </a:stretch>
@@ -684,7 +684,7 @@
           <p:nvPr/>
         </p:nvPicPr>
         <p:blipFill>
-          <a:blip xmlns:r="http://schemas.openxmlformats.org/officeDocument/2006/relationships" xmlns:a="http://schemas.openxmlformats.org/drawingml/2006/main" r:embed="Rdd7874fbeaf14b07"/>
+          <a:blip xmlns:r="http://schemas.openxmlformats.org/officeDocument/2006/relationships" xmlns:a="http://schemas.openxmlformats.org/drawingml/2006/main" r:embed="Rd83edec555b44d71"/>
           <a:stretch xmlns:a="http://schemas.openxmlformats.org/drawingml/2006/main">
             <a:fillRect l="0" t="0" r="0" b="0"/>
           </a:stretch>
@@ -708,7 +708,7 @@
           <p:nvPr/>
         </p:nvPicPr>
         <p:blipFill>
-          <a:blip xmlns:r="http://schemas.openxmlformats.org/officeDocument/2006/relationships" xmlns:a="http://schemas.openxmlformats.org/drawingml/2006/main" r:embed="R43a260f876bb4d15"/>
+          <a:blip xmlns:r="http://schemas.openxmlformats.org/officeDocument/2006/relationships" xmlns:a="http://schemas.openxmlformats.org/drawingml/2006/main" r:embed="R89257d3924114da8"/>
           <a:stretch xmlns:a="http://schemas.openxmlformats.org/drawingml/2006/main">
             <a:fillRect l="0" t="0" r="0" b="0"/>
           </a:stretch>
@@ -875,7 +875,7 @@
   </p:cSld>
   <p:clrMap bg1="lt1" tx1="dk1" bg2="lt2" tx2="dk2" accent1="accent1" accent2="accent2" accent3="accent3" accent4="accent4" accent5="accent5" accent6="accent6" hlink="hlink" folHlink="folHlink"/>
   <p:sldLayoutIdLst>
-    <p:sldLayoutId xmlns:r="http://schemas.openxmlformats.org/officeDocument/2006/relationships" id="2147483649" r:id="Rf741244d75ca4936"/>
+    <p:sldLayoutId xmlns:r="http://schemas.openxmlformats.org/officeDocument/2006/relationships" id="2147483649" r:id="Rc923cd7db9bf4e6c"/>
   </p:sldLayoutIdLst>
   <p:txStyles>
     <p:titleStyle>
@@ -1950,29 +1950,8 @@
             </a:lvl1pPr>
           </a:lstStyle>
           <a:p xmlns:a="http://schemas.openxmlformats.org/drawingml/2006/main">
-            <a:pPr algn="l">
-              <a:lnSpc>
-                <a:spcPct val="94000"/>
-              </a:lnSpc>
-              <a:buNone/>
-              <a:defRPr sz="3225" b="0">
-                <a:solidFill>
-                  <a:srgbClr val="101820"/>
-                </a:solidFill>
-                <a:latin typeface="Arial"/>
-                <a:ea typeface="Arial"/>
-                <a:cs typeface="Arial"/>
-              </a:defRPr>
-            </a:pPr>
-            <a:r>
-              <a:rPr sz="3600" b="0">
-                <a:solidFill>
-                  <a:srgbClr val="101820"/>
-                </a:solidFill>
-                <a:latin typeface="Arial"/>
-                <a:ea typeface="Arial"/>
-                <a:cs typeface="Arial"/>
-              </a:rPr>
+            <a:r>
+              <a:rPr sz="3600"/>
               <a:t>Норма и направление</a:t>
             </a:r>
           </a:p>
@@ -2217,29 +2196,8 @@
             </a:lvl1pPr>
           </a:lstStyle>
           <a:p xmlns:a="http://schemas.openxmlformats.org/drawingml/2006/main">
-            <a:pPr algn="l">
-              <a:lnSpc>
-                <a:spcPct val="94000"/>
-              </a:lnSpc>
-              <a:buNone/>
-              <a:defRPr sz="3225" b="0">
-                <a:solidFill>
-                  <a:srgbClr val="101820"/>
-                </a:solidFill>
-                <a:latin typeface="Arial"/>
-                <a:ea typeface="Arial"/>
-                <a:cs typeface="Arial"/>
-              </a:defRPr>
-            </a:pPr>
-            <a:r>
-              <a:rPr sz="3600" b="0">
-                <a:solidFill>
-                  <a:srgbClr val="101820"/>
-                </a:solidFill>
-                <a:latin typeface="Arial"/>
-                <a:ea typeface="Arial"/>
-                <a:cs typeface="Arial"/>
-              </a:rPr>
+            <a:r>
+              <a:rPr sz="3600"/>
               <a:t>Протокол зафиксирован до оценки</a:t>
             </a:r>
           </a:p>
@@ -2318,7 +2276,7 @@
             </a:r>
             <a:r>
               <a:rPr sz="2400"/>
-              <a:t> замороженная модель, только величина, LoRA, LoRA+ (B/A=16), согласованная по бюджету LoRA, DoRA в бюджете LoRA, полное дообучение.</a:t>
+              <a:t> замороженная модель, только величина, LoRA, LoRA+ (B/A=16), LoRA с бюджетом параметров DoRA, DoRA в рамках бюджета параметров LoRA, полное дообучение.</a:t>
             </a:r>
           </a:p>
           <a:p xmlns:a="http://schemas.openxmlformats.org/drawingml/2006/main">
@@ -2385,29 +2343,8 @@
             </a:lvl1pPr>
           </a:lstStyle>
           <a:p xmlns:a="http://schemas.openxmlformats.org/drawingml/2006/main">
-            <a:pPr algn="l">
-              <a:lnSpc>
-                <a:spcPct val="94000"/>
-              </a:lnSpc>
-              <a:buNone/>
-              <a:defRPr sz="3225" b="0">
-                <a:solidFill>
-                  <a:srgbClr val="101820"/>
-                </a:solidFill>
-                <a:latin typeface="Arial"/>
-                <a:ea typeface="Arial"/>
-                <a:cs typeface="Arial"/>
-              </a:defRPr>
-            </a:pPr>
-            <a:r>
-              <a:rPr sz="3600" b="0">
-                <a:solidFill>
-                  <a:srgbClr val="101820"/>
-                </a:solidFill>
-                <a:latin typeface="Arial"/>
-                <a:ea typeface="Arial"/>
-                <a:cs typeface="Arial"/>
-              </a:rPr>
+            <a:r>
+              <a:rPr sz="3600"/>
               <a:t>Негативные контроли: ограничения</a:t>
             </a:r>
           </a:p>
@@ -2475,7 +2412,7 @@
             </a:r>
             <a:r>
               <a:rPr sz="2400"/>
-              <a:t> согласованная по бюджету параметров LoRA = DoRA = 93.89%.</a:t>
+              <a:t> LoRA с бюджетом параметров DoRA = DoRA = 93.89%.</a:t>
             </a:r>
           </a:p>
           <a:p xmlns:a="http://schemas.openxmlformats.org/drawingml/2006/main">
@@ -2546,29 +2483,8 @@
             </a:lvl1pPr>
           </a:lstStyle>
           <a:p xmlns:a="http://schemas.openxmlformats.org/drawingml/2006/main">
-            <a:pPr algn="l">
-              <a:lnSpc>
-                <a:spcPct val="94000"/>
-              </a:lnSpc>
-              <a:buNone/>
-              <a:defRPr sz="3225" b="0">
-                <a:solidFill>
-                  <a:srgbClr val="101820"/>
-                </a:solidFill>
-                <a:latin typeface="Arial"/>
-                <a:ea typeface="Arial"/>
-                <a:cs typeface="Arial"/>
-              </a:defRPr>
-            </a:pPr>
-            <a:r>
-              <a:rPr sz="3600" b="0">
-                <a:solidFill>
-                  <a:srgbClr val="101820"/>
-                </a:solidFill>
-                <a:latin typeface="Arial"/>
-                <a:ea typeface="Arial"/>
-                <a:cs typeface="Arial"/>
-              </a:rPr>
+            <a:r>
+              <a:rPr sz="3600"/>
               <a:t>Что подтверждают проверки</a:t>
             </a:r>
           </a:p>
@@ -2644,7 +2560,7 @@
             </a:r>
             <a:r>
               <a:rPr sz="2400"/>
-              <a:t> согласованная по бюджету LoRA оставляет +0.53 п.п.; DoRA−LoRA+: p Холма=0.050935; DoRA в бюджете LoRA: +0.82 п.п. (вторичная семья: p Холма=0.347089).</a:t>
+              <a:t> LoRA с бюджетом параметров DoRA оставляет +0.53 п.п.; DoRA−LoRA+: p Холма=0.050935; DoRA в рамках бюджета параметров LoRA: +0.82 п.п. (вторичная семья: p Холма=0.347089).</a:t>
             </a:r>
           </a:p>
           <a:p xmlns:a="http://schemas.openxmlformats.org/drawingml/2006/main">
@@ -3272,7 +3188,7 @@
                 <a:latin typeface="Arial"/>
                 <a:ea typeface="Arial"/>
                 <a:cs typeface="Arial"/>
-                <a:hlinkClick xmlns:r="http://schemas.openxmlformats.org/officeDocument/2006/relationships" r:id="R5b57fb4092694945"/>
+                <a:hlinkClick xmlns:r="http://schemas.openxmlformats.org/officeDocument/2006/relationships" r:id="R01d1d0b912a74c08"/>
               </a:rPr>
               <a:t>ПРИВАТНАЯ ССЫЛКА</a:t>
             </a:r>
@@ -4244,7 +4160,7 @@
           <p:nvPr/>
         </p:nvPicPr>
         <p:blipFill>
-          <a:blip xmlns:r="http://schemas.openxmlformats.org/officeDocument/2006/relationships" xmlns:a="http://schemas.openxmlformats.org/drawingml/2006/main" r:embed="Re90ecb40dd8549ea"/>
+          <a:blip xmlns:r="http://schemas.openxmlformats.org/officeDocument/2006/relationships" xmlns:a="http://schemas.openxmlformats.org/drawingml/2006/main" r:embed="Rc3d7dab3d33b4715"/>
           <a:stretch xmlns:a="http://schemas.openxmlformats.org/drawingml/2006/main"/>
         </p:blipFill>
         <p:spPr>
@@ -4266,7 +4182,7 @@
           <p:nvPr/>
         </p:nvPicPr>
         <p:blipFill>
-          <a:blip xmlns:r="http://schemas.openxmlformats.org/officeDocument/2006/relationships" xmlns:a="http://schemas.openxmlformats.org/drawingml/2006/main" r:embed="R7201ef6f47354cdb"/>
+          <a:blip xmlns:r="http://schemas.openxmlformats.org/officeDocument/2006/relationships" xmlns:a="http://schemas.openxmlformats.org/drawingml/2006/main" r:embed="Rc89fd9a009e34764"/>
           <a:stretch xmlns:a="http://schemas.openxmlformats.org/drawingml/2006/main"/>
         </p:blipFill>
         <p:spPr>

</xml_diff>